<commit_message>
Add the Bottle video, embed it in the deck, and apply the first verification round's fixes
Connectors and Skills menu paths match the current help center (Customize), scheduled
tasks are described as running on Claude's side, Outlook limits are stated, the Monday
signature points at the Drive review, and the fleet's clarity fixes land on every page.

Co-Authored-By: Claude Fable 5.1 <noreply@anthropic.com>
Claude-Session: https://claude.ai/code/session_0193JnwZiFkcYnyNggnZj1Hm
</commit_message>
<xml_diff>
--- a/decks/build-your-own-donna-v3.pptx
+++ b/decks/build-your-own-donna-v3.pptx
@@ -1173,7 +1173,7 @@
             <a:r>
               <a:rPr lang="en-US" dirty="0"/>
               <a:t>[TIMING] 4 min.
-[SAY] You will never re-explain your rules again. That is the difference between a chat and a project.
+[SAY] You will never re-explain your rules again. That is the difference between a chat and a playbook.
 [DO] Gate first: is THE FINAL QUESTION on your screen? Anyone who is not there types: final question. After the OPEN FOR BUSINESS banner, everyone runs the one-sentence ritual inside the project. Hold until the checkmarks say every screen shows a table.
 [WATCH] Reply-Now drafts are already sitting in their Drafts folder. Have them check; that is the gasp.
 [NEXT] Step three. The document leaves your hands.</a:t>
@@ -1451,7 +1451,7 @@
               <a:t>[TIMING] 6 min.
 [SAY] The last line of that prompt is the finale of this step: a dry run, right now, with today's event ten minutes out so the email lands while we are still together.
 [DO] Grab the prompt from the site rather than retyping. Scheduled in the left sidebar, New task, Create with Claude. If Claude asks how much she may do without checking in, pick the hands-free option. If someone cannot find Scheduled, the rescue prompt on the page asks Claude where it is.
-[WATCH] Scheduled tasks run while the laptop is awake and the app is open. Say that plainly rather than promising something the product does not do. 'My local time' matters: half this room is in Europe.
+[WATCH] Scheduled tasks run on Anthropic's side now, so a closed laptop is fine; say that plainly. 'My local time' matters: half this room is in Europe. Paste by 12:51 at the latest so the event lands before step four.
 [NEXT] Everybody watch your calendar.</a:t>
             </a:r>
             <a:endParaRPr lang="en-US" dirty="0"/>
@@ -1633,9 +1633,9 @@
             <a:r>
               <a:rPr lang="en-US" dirty="0"/>
               <a:t>[TIMING] 4 min.
-[SAY] Nothing. Let the calendars ping.
-[DO] Everyone watches the dry run land: event on today's calendar with the whole triage in its description, drafts waiting, the email a minute out. Hold the silence. Checkmarks in the chat.
-[WATCH] If a few are still waiting when the clock says 12:58, move on. The event lands while step four starts and they will see it.
+[SAY] Open today's calendar. The checkmark is the event with the triage inside it. The email arrives a minute before it starts, right as step four begins.
+[DO] Everyone opens the event: the whole triage in its description, drafts waiting. Hold the silence. Checkmarks in the chat.
+[WATCH] The event appears when the dry run finishes, two to five minutes after the paste; the email follows ten minutes after the task started, so most land around 1:00. Do not wait for the email here. Move on at 12:58 and let it arrive during step four.
 [NEXT] Three stations lit. Now the one almost nobody builds.</a:t>
             </a:r>
             <a:endParaRPr lang="en-US" dirty="0"/>
@@ -1818,8 +1818,8 @@
               <a:rPr lang="en-US" dirty="0"/>
               <a:t>[TIMING] 10 min.
 [SAY] Your Sent folder is her report card. She reads the reports she wrote, the drafts she saved, and the emails you actually sent, and she proposes changes to her own playbook. Numbered, each with a because. Nothing changes until you say approve.
-[DO] Same place as the daily shift: Scheduled, New task, paste. The last line runs it right now on this week so far, with today's event ten minutes out. Yes, on a Wednesday: the Sent folder since Monday gives her plenty to say.
-[WATCH] Someone will ask whether she can just apply the changes herself. No, and that is the point: the human signature is what closes the loop. Monday, three moves, only when she proposes something.
+[DO] Paste first, by 1:01, then talk. Same place as the daily shift: Scheduled, New task, paste. The last line runs it right now on this week so far, with today's event ten minutes out, which lands at 1:11 if the paste is at 1:01. Talk through the Sent-folder idea while she reads the week. Yes, on a Wednesday: the Sent folder since Monday gives her plenty to say.
+[WATCH] Someone will ask whether she can just apply the changes herself. No, and that is the point: the human signature is what closes the loop. Monday, one paste and one upload, only when she proposes something.
 [NEXT] Watch for the review.</a:t>
             </a:r>
             <a:endParaRPr lang="en-US" dirty="0"/>
@@ -2185,7 +2185,7 @@
             <a:r>
               <a:rPr lang="en-US" dirty="0"/>
               <a:t>[TIMING] 3 min.
-[SAY] Tomorrow at 4:30 she works her first real shift, and the email lands at 4:39. Friday at 3:00 she reads her week. Monday at 8:00 her Week in Review is on your calendar, and you sign it in three clicks. If she gets it wrong, you do not need a better prompt. You need a Friday.
+[SAY] Tomorrow at 4:30 she works her first real shift, and the email lands at 4:39. Friday at 3:00 she reads her week. Monday at 8:00 her Week in Review is on your calendar, and you sign it with one paste and one upload. If she gets it wrong, you do not need a better prompt. You need a Friday.
 [DO] Point at Monday. That is the loop closing for the first time without you in the room.
 [WATCH] The site stays up: every prompt, every rescue prompt, the Monday signature. Questions to the email address, any time.
 [NEXT] Send-off.</a:t>
@@ -2829,7 +2829,7 @@
               <a:t>[TIMING] 1 min.
 [SAY] Say it twice, verbatim: she never sends. Ever. And she never deletes.
 [DO] Slow down here. This is the trust slide, and it answers the fear nobody has typed in the chat yet: what if it emails a client?
-[WATCH] It cannot. Drafting and sending are different permissions, and this playbook only ever drafts. You are the send button. If someone asks about privacy, the appendix has the plan-by-plan answer; do not go there now.
+[WATCH] Her playbook forbids it in its first line, and nothing leaves until you press send on a draft you have read. You are the send button. If someone asks about privacy, the appendix has the plan-by-plan answer; do not go there now.
 [NEXT] Five house rules, then we build.</a:t>
             </a:r>
             <a:endParaRPr lang="en-US" dirty="0"/>
@@ -7572,7 +7572,7 @@
                 <a:ea typeface="Arial" pitchFamily="34" charset="-122"/>
                 <a:cs typeface="Arial" pitchFamily="34" charset="-120"/>
               </a:rPr>
-              <a:t>Your initials, then Settings, then Connectors.</a:t>
+              <a:t>Customize, then Connectors.</a:t>
             </a:r>
             <a:endParaRPr lang="en-US" sz="1300" dirty="0"/>
           </a:p>
@@ -8634,7 +8634,7 @@
                 <a:ea typeface="Arial" pitchFamily="34" charset="-122"/>
                 <a:cs typeface="Arial" pitchFamily="34" charset="-120"/>
               </a:rPr>
-              <a:t>The interview is over. She’s hired. Now we train her.</a:t>
+              <a:t>The interview is over. She’s hired. Now we teach her.</a:t>
             </a:r>
             <a:endParaRPr lang="en-US" sz="1700" dirty="0"/>
           </a:p>
@@ -10886,7 +10886,7 @@
                 <a:ea typeface="Arial" pitchFamily="34" charset="-122"/>
                 <a:cs typeface="Arial" pitchFamily="34" charset="-120"/>
               </a:rPr>
-              <a:t>Chat is a conversation. A project is a standing arrangement.</a:t>
+              <a:t>Chat is a conversation. A playbook is a standing arrangement.</a:t>
             </a:r>
             <a:endParaRPr lang="en-US" sz="1700" dirty="0"/>
           </a:p>
@@ -12410,7 +12410,7 @@
                 <a:ea typeface="Arial" pitchFamily="34" charset="-122"/>
                 <a:cs typeface="Arial" pitchFamily="34" charset="-120"/>
               </a:rPr>
-              <a:t>Settings, then Capabilities, then Skills, then Upload skill. Pick the zip.</a:t>
+              <a:t>Customize, then Skills, then Create skill, then Upload a skill. Pick the zip.</a:t>
             </a:r>
             <a:endParaRPr lang="en-US" sz="1400" dirty="0"/>
           </a:p>
@@ -13403,7 +13403,7 @@
                 <a:ea typeface="Arial" pitchFamily="34" charset="-122"/>
                 <a:cs typeface="Arial" pitchFamily="34" charset="-120"/>
               </a:rPr>
-              <a:t>WHILE YOUR LAPTOP IS OPEN</a:t>
+              <a:t>WHERE SHE RUNS</a:t>
             </a:r>
             <a:endParaRPr lang="en-US" sz="1200" dirty="0"/>
           </a:p>
@@ -13470,7 +13470,7 @@
                 <a:ea typeface="Arial" pitchFamily="34" charset="-122"/>
                 <a:cs typeface="Arial" pitchFamily="34" charset="-120"/>
               </a:rPr>
-              <a:t>She works while your laptop is awake and Claude is open. Close it, she waits. Open it, she catches up.</a:t>
+              <a:t>Scheduled tasks run on Claude's side, not on your laptop. Close the laptop; she still works at 4:30.</a:t>
             </a:r>
             <a:endParaRPr lang="en-US" sz="1200" dirty="0"/>
           </a:p>
@@ -13547,12 +13547,29 @@
           </a:p>
         </p:txBody>
       </p:sp>
-      <p:sp>
-        <p:nvSpPr>
-          <p:cNvPr id="3" name="Shape 1"/>
-          <p:cNvSpPr/>
-          <p:nvPr/>
-        </p:nvSpPr>
+      <p:pic>
+        <p:nvPicPr>
+          <p:cNvPr id="3" name="Media 0">
+            <a:hlinkClick r:id="" action="ppaction://media"/>
+          </p:cNvPr>
+          <p:cNvPicPr>
+            <a:picLocks noChangeAspect="1"/>
+          </p:cNvPicPr>
+          <p:nvPr>
+            <a:videoFile r:link="rId1"/>
+            <p:extLst>
+              <p:ext uri="{DAA4B4D4-6D71-4841-9C94-3DE7FCFB9230}">
+                <p14:media xmlns:p14="http://schemas.microsoft.com/office/powerpoint/2010/main" r:embed="rId2"/>
+              </p:ext>
+            </p:extLst>
+          </p:nvPr>
+        </p:nvPicPr>
+        <p:blipFill>
+          <a:blip r:embed="rId3"/>
+          <a:stretch>
+            <a:fillRect/>
+          </a:stretch>
+        </p:blipFill>
         <p:spPr>
           <a:xfrm>
             <a:off x="975208" y="640080"/>
@@ -13561,55 +13578,8 @@
           <a:prstGeom prst="rect">
             <a:avLst/>
           </a:prstGeom>
-          <a:ln w="9525">
-            <a:solidFill>
-              <a:srgbClr val="C9A227">
-                <a:alpha val="60000"/>
-              </a:srgbClr>
-            </a:solidFill>
-            <a:prstDash val="solid"/>
-          </a:ln>
-        </p:spPr>
-      </p:sp>
-      <p:sp>
-        <p:nvSpPr>
-          <p:cNvPr id="4" name="Text 2"/>
-          <p:cNvSpPr/>
-          <p:nvPr/>
-        </p:nvSpPr>
-        <p:spPr>
-          <a:xfrm>
-            <a:off x="975208" y="3337560"/>
-            <a:ext cx="10241280" cy="365760"/>
-          </a:xfrm>
-          <a:prstGeom prst="rect">
-            <a:avLst/>
-          </a:prstGeom>
-          <a:noFill/>
-          <a:ln/>
-        </p:spPr>
-        <p:txBody>
-          <a:bodyPr wrap="square" lIns="0" tIns="0" rIns="0" bIns="0" rtlCol="0" anchor="ctr"/>
-          <a:lstStyle/>
-          <a:p>
-            <a:pPr algn="ctr" indent="0" marL="0">
-              <a:buNone/>
-            </a:pPr>
-            <a:r>
-              <a:rPr lang="en-US" sz="1300" i="1" dirty="0">
-                <a:solidFill>
-                  <a:srgbClr val="AFA893"/>
-                </a:solidFill>
-                <a:latin typeface="Arial" pitchFamily="34" charset="0"/>
-                <a:ea typeface="Arial" pitchFamily="34" charset="-122"/>
-                <a:cs typeface="Arial" pitchFamily="34" charset="-120"/>
-              </a:rPr>
-              <a:t>The Bottle · assets/video/the-bottle.mp4</a:t>
-            </a:r>
-            <a:endParaRPr lang="en-US" sz="1300" dirty="0"/>
-          </a:p>
-        </p:txBody>
-      </p:sp>
+        </p:spPr>
+      </p:pic>
     </p:spTree>
   </p:cSld>
   <p:clrMapOvr>
@@ -14079,7 +14049,7 @@
                 <a:ea typeface="Georgia" pitchFamily="34" charset="-122"/>
                 <a:cs typeface="Georgia" pitchFamily="34" charset="-120"/>
               </a:rPr>
-              <a:t>Her first shift lands before the last step starts.</a:t>
+              <a:t>Her first shift lands as the last step starts.</a:t>
             </a:r>
             <a:endParaRPr lang="en-US" sz="3200" dirty="0"/>
           </a:p>
@@ -18811,7 +18781,7 @@
                 <a:ea typeface="Arial" pitchFamily="34" charset="-122"/>
                 <a:cs typeface="Arial" pitchFamily="34" charset="-120"/>
               </a:rPr>
-              <a:t>Mon, 3 clicks</a:t>
+              <a:t>Mon, you sign it</a:t>
             </a:r>
             <a:endParaRPr lang="en-US" sz="1300" dirty="0"/>
           </a:p>
@@ -18853,7 +18823,7 @@
                 <a:ea typeface="Arial" pitchFamily="34" charset="-122"/>
                 <a:cs typeface="Arial" pitchFamily="34" charset="-120"/>
               </a:rPr>
-              <a:t>you sign it</a:t>
+              <a:t>one paste, one upload</a:t>
             </a:r>
             <a:endParaRPr lang="en-US" sz="1100" dirty="0"/>
           </a:p>
@@ -21189,12 +21159,20 @@
           </a:p>
         </p:txBody>
       </p:sp>
-      <p:sp>
-        <p:nvSpPr>
-          <p:cNvPr id="3" name="Shape 1"/>
-          <p:cNvSpPr/>
-          <p:nvPr/>
-        </p:nvSpPr>
+      <p:pic>
+        <p:nvPicPr>
+          <p:cNvPr id="3" name="Image 0" descr="assets/video/the-bottle-1.png">    </p:cNvPr>
+          <p:cNvPicPr>
+            <a:picLocks noChangeAspect="1"/>
+          </p:cNvPicPr>
+          <p:nvPr/>
+        </p:nvPicPr>
+        <p:blipFill>
+          <a:blip r:embed="rId1"/>
+          <a:stretch>
+            <a:fillRect/>
+          </a:stretch>
+        </p:blipFill>
         <p:spPr>
           <a:xfrm>
             <a:off x="813816" y="1188720"/>
@@ -21203,15 +21181,11 @@
           <a:prstGeom prst="rect">
             <a:avLst/>
           </a:prstGeom>
-          <a:solidFill>
-            <a:srgbClr val="2A3244"/>
-          </a:solidFill>
-          <a:ln/>
-        </p:spPr>
-      </p:sp>
-      <p:sp>
-        <p:nvSpPr>
-          <p:cNvPr id="4" name="Text 2"/>
+        </p:spPr>
+      </p:pic>
+      <p:sp>
+        <p:nvSpPr>
+          <p:cNvPr id="4" name="Text 1"/>
           <p:cNvSpPr/>
           <p:nvPr/>
         </p:nvSpPr>
@@ -21251,12 +21225,20 @@
           </a:p>
         </p:txBody>
       </p:sp>
-      <p:sp>
-        <p:nvSpPr>
-          <p:cNvPr id="5" name="Shape 3"/>
-          <p:cNvSpPr/>
-          <p:nvPr/>
-        </p:nvSpPr>
+      <p:pic>
+        <p:nvPicPr>
+          <p:cNvPr id="5" name="Image 1" descr="assets/video/the-bottle-2.png">    </p:cNvPr>
+          <p:cNvPicPr>
+            <a:picLocks noChangeAspect="1"/>
+          </p:cNvPicPr>
+          <p:nvPr/>
+        </p:nvPicPr>
+        <p:blipFill>
+          <a:blip r:embed="rId2"/>
+          <a:stretch>
+            <a:fillRect/>
+          </a:stretch>
+        </p:blipFill>
         <p:spPr>
           <a:xfrm>
             <a:off x="4471416" y="1188720"/>
@@ -21265,15 +21247,11 @@
           <a:prstGeom prst="rect">
             <a:avLst/>
           </a:prstGeom>
-          <a:solidFill>
-            <a:srgbClr val="2A3244"/>
-          </a:solidFill>
-          <a:ln/>
-        </p:spPr>
-      </p:sp>
-      <p:sp>
-        <p:nvSpPr>
-          <p:cNvPr id="6" name="Text 4"/>
+        </p:spPr>
+      </p:pic>
+      <p:sp>
+        <p:nvSpPr>
+          <p:cNvPr id="6" name="Text 2"/>
           <p:cNvSpPr/>
           <p:nvPr/>
         </p:nvSpPr>
@@ -21313,12 +21291,20 @@
           </a:p>
         </p:txBody>
       </p:sp>
-      <p:sp>
-        <p:nvSpPr>
-          <p:cNvPr id="7" name="Shape 5"/>
-          <p:cNvSpPr/>
-          <p:nvPr/>
-        </p:nvSpPr>
+      <p:pic>
+        <p:nvPicPr>
+          <p:cNvPr id="7" name="Image 2" descr="assets/video/the-bottle-3.png">    </p:cNvPr>
+          <p:cNvPicPr>
+            <a:picLocks noChangeAspect="1"/>
+          </p:cNvPicPr>
+          <p:nvPr/>
+        </p:nvPicPr>
+        <p:blipFill>
+          <a:blip r:embed="rId3"/>
+          <a:stretch>
+            <a:fillRect/>
+          </a:stretch>
+        </p:blipFill>
         <p:spPr>
           <a:xfrm>
             <a:off x="8129016" y="1188720"/>
@@ -21327,15 +21313,11 @@
           <a:prstGeom prst="rect">
             <a:avLst/>
           </a:prstGeom>
-          <a:solidFill>
-            <a:srgbClr val="2A3244"/>
-          </a:solidFill>
-          <a:ln/>
-        </p:spPr>
-      </p:sp>
-      <p:sp>
-        <p:nvSpPr>
-          <p:cNvPr id="8" name="Text 6"/>
+        </p:spPr>
+      </p:pic>
+      <p:sp>
+        <p:nvSpPr>
+          <p:cNvPr id="8" name="Text 3"/>
           <p:cNvSpPr/>
           <p:nvPr/>
         </p:nvSpPr>
@@ -21377,7 +21359,7 @@
       </p:sp>
       <p:sp>
         <p:nvSpPr>
-          <p:cNvPr id="9" name="Shape 7"/>
+          <p:cNvPr id="9" name="Shape 4"/>
           <p:cNvSpPr/>
           <p:nvPr/>
         </p:nvSpPr>
@@ -21400,7 +21382,7 @@
       </p:sp>
       <p:sp>
         <p:nvSpPr>
-          <p:cNvPr id="10" name="Text 8"/>
+          <p:cNvPr id="10" name="Text 5"/>
           <p:cNvSpPr/>
           <p:nvPr/>
         </p:nvSpPr>
@@ -21439,7 +21421,7 @@
       </p:sp>
       <p:sp>
         <p:nvSpPr>
-          <p:cNvPr id="11" name="Shape 9"/>
+          <p:cNvPr id="11" name="Shape 6"/>
           <p:cNvSpPr/>
           <p:nvPr/>
         </p:nvSpPr>
@@ -21464,7 +21446,7 @@
       </p:sp>
       <p:sp>
         <p:nvSpPr>
-          <p:cNvPr id="12" name="Text 10"/>
+          <p:cNvPr id="12" name="Text 7"/>
           <p:cNvSpPr/>
           <p:nvPr/>
         </p:nvSpPr>

</xml_diff>

<commit_message>
Visual QA fixes: clockwise arrows, slide 3 layout, pip placement, headline widths, phone-friendly prompt wrapping; round-2 copy fixes
Co-Authored-By: Claude Fable 5.1 <noreply@anthropic.com>
Claude-Session: https://claude.ai/code/session_0193JnwZiFkcYnyNggnZj1Hm
</commit_message>
<xml_diff>
--- a/decks/build-your-own-donna-v3.pptx
+++ b/decks/build-your-own-donna-v3.pptx
@@ -6676,7 +6676,7 @@
         </p:nvSpPr>
         <p:spPr>
           <a:xfrm>
-            <a:off x="10954512" y="402336"/>
+            <a:off x="10899648" y="475488"/>
             <a:ext cx="402336" cy="402336"/>
           </a:xfrm>
           <a:prstGeom prst="ellipse">
@@ -6698,7 +6698,7 @@
         </p:nvSpPr>
         <p:spPr>
           <a:xfrm>
-            <a:off x="11098530" y="345186"/>
+            <a:off x="11043666" y="418338"/>
             <a:ext cx="114300" cy="114300"/>
           </a:xfrm>
           <a:prstGeom prst="ellipse">
@@ -6723,7 +6723,7 @@
         </p:nvSpPr>
         <p:spPr>
           <a:xfrm>
-            <a:off x="11299698" y="546354"/>
+            <a:off x="11244834" y="619506"/>
             <a:ext cx="114300" cy="114300"/>
           </a:xfrm>
           <a:prstGeom prst="ellipse">
@@ -6748,7 +6748,7 @@
         </p:nvSpPr>
         <p:spPr>
           <a:xfrm>
-            <a:off x="11098530" y="747522"/>
+            <a:off x="11043666" y="820674"/>
             <a:ext cx="114300" cy="114300"/>
           </a:xfrm>
           <a:prstGeom prst="ellipse">
@@ -6773,7 +6773,7 @@
         </p:nvSpPr>
         <p:spPr>
           <a:xfrm>
-            <a:off x="10897362" y="546354"/>
+            <a:off x="10842498" y="619506"/>
             <a:ext cx="114300" cy="114300"/>
           </a:xfrm>
           <a:prstGeom prst="ellipse">
@@ -6798,8 +6798,8 @@
         </p:nvSpPr>
         <p:spPr>
           <a:xfrm>
-            <a:off x="9189720" y="841248"/>
-            <a:ext cx="2194560" cy="164592"/>
+            <a:off x="10775290" y="932688"/>
+            <a:ext cx="608990" cy="164592"/>
           </a:xfrm>
           <a:prstGeom prst="rect">
             <a:avLst/>
@@ -7151,7 +7151,7 @@
         </p:nvSpPr>
         <p:spPr>
           <a:xfrm>
-            <a:off x="10954512" y="402336"/>
+            <a:off x="10899648" y="475488"/>
             <a:ext cx="402336" cy="402336"/>
           </a:xfrm>
           <a:prstGeom prst="ellipse">
@@ -7173,7 +7173,7 @@
         </p:nvSpPr>
         <p:spPr>
           <a:xfrm>
-            <a:off x="11098530" y="345186"/>
+            <a:off x="11043666" y="418338"/>
             <a:ext cx="114300" cy="114300"/>
           </a:xfrm>
           <a:prstGeom prst="ellipse">
@@ -7198,7 +7198,7 @@
         </p:nvSpPr>
         <p:spPr>
           <a:xfrm>
-            <a:off x="11299698" y="546354"/>
+            <a:off x="11244834" y="619506"/>
             <a:ext cx="114300" cy="114300"/>
           </a:xfrm>
           <a:prstGeom prst="ellipse">
@@ -7223,7 +7223,7 @@
         </p:nvSpPr>
         <p:spPr>
           <a:xfrm>
-            <a:off x="11098530" y="747522"/>
+            <a:off x="11043666" y="820674"/>
             <a:ext cx="114300" cy="114300"/>
           </a:xfrm>
           <a:prstGeom prst="ellipse">
@@ -7248,7 +7248,7 @@
         </p:nvSpPr>
         <p:spPr>
           <a:xfrm>
-            <a:off x="10897362" y="546354"/>
+            <a:off x="10842498" y="619506"/>
             <a:ext cx="114300" cy="114300"/>
           </a:xfrm>
           <a:prstGeom prst="ellipse">
@@ -7273,8 +7273,8 @@
         </p:nvSpPr>
         <p:spPr>
           <a:xfrm>
-            <a:off x="9189720" y="841248"/>
-            <a:ext cx="2194560" cy="164592"/>
+            <a:off x="10775290" y="932688"/>
+            <a:ext cx="608990" cy="164592"/>
           </a:xfrm>
           <a:prstGeom prst="rect">
             <a:avLst/>
@@ -7352,7 +7352,7 @@
         <p:spPr>
           <a:xfrm>
             <a:off x="813816" y="841248"/>
-            <a:ext cx="10570464" cy="751027"/>
+            <a:ext cx="9418320" cy="653735"/>
           </a:xfrm>
           <a:prstGeom prst="rect">
             <a:avLst/>
@@ -7371,7 +7371,7 @@
               <a:buNone/>
             </a:pPr>
             <a:r>
-              <a:rPr lang="en-US" sz="4000" b="1" dirty="0">
+              <a:rPr lang="en-US" sz="3400" b="1" dirty="0">
                 <a:solidFill>
                   <a:srgbClr val="14213D"/>
                 </a:solidFill>
@@ -7381,7 +7381,7 @@
               </a:rPr>
               <a:t>Create her project, then connect.</a:t>
             </a:r>
-            <a:endParaRPr lang="en-US" sz="4000" dirty="0"/>
+            <a:endParaRPr lang="en-US" sz="3400" dirty="0"/>
           </a:p>
         </p:txBody>
       </p:sp>
@@ -7393,7 +7393,7 @@
         </p:nvSpPr>
         <p:spPr>
           <a:xfrm>
-            <a:off x="813816" y="1775155"/>
+            <a:off x="813816" y="1677863"/>
             <a:ext cx="5687568" cy="2039112"/>
           </a:xfrm>
           <a:prstGeom prst="rect">
@@ -7413,7 +7413,7 @@
         </p:nvSpPr>
         <p:spPr>
           <a:xfrm>
-            <a:off x="1051560" y="2012899"/>
+            <a:off x="1051560" y="1915607"/>
             <a:ext cx="5212080" cy="299466"/>
           </a:xfrm>
           <a:prstGeom prst="rect">
@@ -7452,7 +7452,7 @@
         </p:nvSpPr>
         <p:spPr>
           <a:xfrm rot="2700000">
-            <a:off x="1051560" y="2499817"/>
+            <a:off x="1051560" y="2402525"/>
             <a:ext cx="100584" cy="100584"/>
           </a:xfrm>
           <a:prstGeom prst="rect">
@@ -7477,7 +7477,7 @@
         </p:nvSpPr>
         <p:spPr>
           <a:xfrm>
-            <a:off x="1362456" y="2422093"/>
+            <a:off x="1362456" y="2324801"/>
             <a:ext cx="4901184" cy="299466"/>
           </a:xfrm>
           <a:prstGeom prst="rect">
@@ -7519,7 +7519,7 @@
         </p:nvSpPr>
         <p:spPr>
           <a:xfrm rot="2700000">
-            <a:off x="1051560" y="2927299"/>
+            <a:off x="1051560" y="2830007"/>
             <a:ext cx="100584" cy="100584"/>
           </a:xfrm>
           <a:prstGeom prst="rect">
@@ -7544,7 +7544,7 @@
         </p:nvSpPr>
         <p:spPr>
           <a:xfrm>
-            <a:off x="1362456" y="2849575"/>
+            <a:off x="1362456" y="2752283"/>
             <a:ext cx="4901184" cy="299466"/>
           </a:xfrm>
           <a:prstGeom prst="rect">
@@ -7586,7 +7586,7 @@
         </p:nvSpPr>
         <p:spPr>
           <a:xfrm rot="2700000">
-            <a:off x="1051560" y="3354781"/>
+            <a:off x="1051560" y="3257489"/>
             <a:ext cx="100584" cy="100584"/>
           </a:xfrm>
           <a:prstGeom prst="rect">
@@ -7611,7 +7611,7 @@
         </p:nvSpPr>
         <p:spPr>
           <a:xfrm>
-            <a:off x="1362456" y="3277057"/>
+            <a:off x="1362456" y="3179765"/>
             <a:ext cx="4901184" cy="299466"/>
           </a:xfrm>
           <a:prstGeom prst="rect">
@@ -7653,8 +7653,8 @@
         </p:nvSpPr>
         <p:spPr>
           <a:xfrm>
-            <a:off x="813816" y="3923995"/>
-            <a:ext cx="5687568" cy="1609344"/>
+            <a:off x="813816" y="3991295"/>
+            <a:ext cx="5687568" cy="1234440"/>
           </a:xfrm>
           <a:prstGeom prst="rect">
             <a:avLst/>
@@ -7673,7 +7673,7 @@
         </p:nvSpPr>
         <p:spPr>
           <a:xfrm>
-            <a:off x="996696" y="4106875"/>
+            <a:off x="996696" y="4174175"/>
             <a:ext cx="5321808" cy="283464"/>
           </a:xfrm>
           <a:prstGeom prst="rect">
@@ -7712,7 +7712,7 @@
         </p:nvSpPr>
         <p:spPr>
           <a:xfrm rot="2700000">
-            <a:off x="996696" y="4577791"/>
+            <a:off x="996696" y="4645091"/>
             <a:ext cx="100584" cy="100584"/>
           </a:xfrm>
           <a:prstGeom prst="rect">
@@ -7737,8 +7737,8 @@
         </p:nvSpPr>
         <p:spPr>
           <a:xfrm>
-            <a:off x="1307592" y="4500067"/>
-            <a:ext cx="5010912" cy="283464"/>
+            <a:off x="1307592" y="4567367"/>
+            <a:ext cx="5010912" cy="475488"/>
           </a:xfrm>
           <a:prstGeom prst="rect">
             <a:avLst/>
@@ -7765,7 +7765,7 @@
                 <a:ea typeface="Arial" pitchFamily="34" charset="-122"/>
                 <a:cs typeface="Arial" pitchFamily="34" charset="-120"/>
               </a:rPr>
-              <a:t>Quit Claude and reopen it. Fixes it nine times out of ten.</a:t>
+              <a:t>Quit Claude and reopen it. IT blocks it? Use a personal Gmail. Still stuck: the rescue prompt is on the site, Step 1.</a:t>
             </a:r>
             <a:endParaRPr lang="en-US" sz="1200" dirty="0"/>
           </a:p>
@@ -7778,22 +7778,17 @@
           <p:nvPr/>
         </p:nvSpPr>
         <p:spPr>
-          <a:xfrm rot="2700000">
-            <a:off x="996696" y="4952695"/>
-            <a:ext cx="100584" cy="100584"/>
+          <a:xfrm>
+            <a:off x="6903720" y="1677863"/>
+            <a:ext cx="4480560" cy="1239012"/>
           </a:xfrm>
           <a:prstGeom prst="rect">
             <a:avLst/>
           </a:prstGeom>
           <a:solidFill>
-            <a:srgbClr val="C9A227"/>
+            <a:srgbClr val="14213D"/>
           </a:solidFill>
-          <a:ln w="3175">
-            <a:solidFill>
-              <a:srgbClr val="C9A227"/>
-            </a:solidFill>
-            <a:prstDash val="solid"/>
-          </a:ln>
+          <a:ln/>
         </p:spPr>
       </p:sp>
       <p:sp>
@@ -7804,93 +7799,31 @@
         </p:nvSpPr>
         <p:spPr>
           <a:xfrm>
-            <a:off x="1307592" y="4874971"/>
-            <a:ext cx="5010912" cy="475488"/>
-          </a:xfrm>
-          <a:prstGeom prst="rect">
-            <a:avLst/>
-          </a:prstGeom>
-          <a:noFill/>
-          <a:ln/>
-        </p:spPr>
-        <p:txBody>
-          <a:bodyPr wrap="square" lIns="0" tIns="0" rIns="0" bIns="0" rtlCol="0" anchor="t"/>
+            <a:off x="7159752" y="1851599"/>
+            <a:ext cx="3968496" cy="201168"/>
+          </a:xfrm>
+          <a:prstGeom prst="rect">
+            <a:avLst/>
+          </a:prstGeom>
+          <a:noFill/>
+          <a:ln/>
+        </p:spPr>
+        <p:txBody>
+          <a:bodyPr wrap="square" lIns="0" tIns="0" rIns="0" bIns="0" rtlCol="0" anchor="ctr"/>
           <a:lstStyle/>
           <a:p>
             <a:pPr indent="0" marL="0">
-              <a:lnSpc>
-                <a:spcPct val="116000"/>
-              </a:lnSpc>
-              <a:buNone/>
-            </a:pPr>
-            <a:r>
-              <a:rPr lang="en-US" sz="1200" dirty="0">
-                <a:solidFill>
-                  <a:srgbClr val="14213D"/>
+              <a:buNone/>
+            </a:pPr>
+            <a:r>
+              <a:rPr lang="en-US" sz="1100" b="1" spc="160" kern="0" dirty="0">
+                <a:solidFill>
+                  <a:srgbClr val="E7C766"/>
                 </a:solidFill>
                 <a:latin typeface="Arial" pitchFamily="34" charset="0"/>
                 <a:ea typeface="Arial" pitchFamily="34" charset="-122"/>
                 <a:cs typeface="Arial" pitchFamily="34" charset="-120"/>
               </a:rPr>
-              <a:t>IT blocks it? Use a personal Gmail. Rescue prompt: site, Step 1.</a:t>
-            </a:r>
-            <a:endParaRPr lang="en-US" sz="1200" dirty="0"/>
-          </a:p>
-        </p:txBody>
-      </p:sp>
-      <p:sp>
-        <p:nvSpPr>
-          <p:cNvPr id="29" name="Shape 27"/>
-          <p:cNvSpPr/>
-          <p:nvPr/>
-        </p:nvSpPr>
-        <p:spPr>
-          <a:xfrm>
-            <a:off x="6903720" y="1775155"/>
-            <a:ext cx="4480560" cy="1239012"/>
-          </a:xfrm>
-          <a:prstGeom prst="rect">
-            <a:avLst/>
-          </a:prstGeom>
-          <a:solidFill>
-            <a:srgbClr val="14213D"/>
-          </a:solidFill>
-          <a:ln/>
-        </p:spPr>
-      </p:sp>
-      <p:sp>
-        <p:nvSpPr>
-          <p:cNvPr id="30" name="Text 28"/>
-          <p:cNvSpPr/>
-          <p:nvPr/>
-        </p:nvSpPr>
-        <p:spPr>
-          <a:xfrm>
-            <a:off x="7159752" y="1948891"/>
-            <a:ext cx="3968496" cy="201168"/>
-          </a:xfrm>
-          <a:prstGeom prst="rect">
-            <a:avLst/>
-          </a:prstGeom>
-          <a:noFill/>
-          <a:ln/>
-        </p:spPr>
-        <p:txBody>
-          <a:bodyPr wrap="square" lIns="0" tIns="0" rIns="0" bIns="0" rtlCol="0" anchor="ctr"/>
-          <a:lstStyle/>
-          <a:p>
-            <a:pPr indent="0" marL="0">
-              <a:buNone/>
-            </a:pPr>
-            <a:r>
-              <a:rPr lang="en-US" sz="1100" b="1" spc="160" kern="0" dirty="0">
-                <a:solidFill>
-                  <a:srgbClr val="E7C766"/>
-                </a:solidFill>
-                <a:latin typeface="Arial" pitchFamily="34" charset="0"/>
-                <a:ea typeface="Arial" pitchFamily="34" charset="-122"/>
-                <a:cs typeface="Arial" pitchFamily="34" charset="-120"/>
-              </a:rPr>
               <a:t>PROMPT 1 · THE QUESTION</a:t>
             </a:r>
             <a:endParaRPr lang="en-US" sz="1100" dirty="0"/>
@@ -7899,13 +7832,13 @@
       </p:sp>
       <p:sp>
         <p:nvSpPr>
-          <p:cNvPr id="31" name="Text 29"/>
-          <p:cNvSpPr/>
-          <p:nvPr/>
-        </p:nvSpPr>
-        <p:spPr>
-          <a:xfrm>
-            <a:off x="7159752" y="2232355"/>
+          <p:cNvPr id="29" name="Text 27"/>
+          <p:cNvSpPr/>
+          <p:nvPr/>
+        </p:nvSpPr>
+        <p:spPr>
+          <a:xfrm>
+            <a:off x="7159752" y="2135063"/>
             <a:ext cx="3968496" cy="690372"/>
           </a:xfrm>
           <a:prstGeom prst="rect">
@@ -7981,13 +7914,13 @@
       </p:sp>
       <p:sp>
         <p:nvSpPr>
-          <p:cNvPr id="32" name="Shape 30"/>
-          <p:cNvSpPr/>
-          <p:nvPr/>
-        </p:nvSpPr>
-        <p:spPr>
-          <a:xfrm>
-            <a:off x="6903720" y="3233623"/>
+          <p:cNvPr id="30" name="Shape 28"/>
+          <p:cNvSpPr/>
+          <p:nvPr/>
+        </p:nvSpPr>
+        <p:spPr>
+          <a:xfrm>
+            <a:off x="6903720" y="3136331"/>
             <a:ext cx="4480560" cy="1426464"/>
           </a:xfrm>
           <a:prstGeom prst="rect">
@@ -8001,13 +7934,13 @@
       </p:sp>
       <p:sp>
         <p:nvSpPr>
-          <p:cNvPr id="33" name="Text 31"/>
-          <p:cNvSpPr/>
-          <p:nvPr/>
-        </p:nvSpPr>
-        <p:spPr>
-          <a:xfrm>
-            <a:off x="7159752" y="3407359"/>
+          <p:cNvPr id="31" name="Text 29"/>
+          <p:cNvSpPr/>
+          <p:nvPr/>
+        </p:nvSpPr>
+        <p:spPr>
+          <a:xfrm>
+            <a:off x="7159752" y="3310067"/>
             <a:ext cx="3968496" cy="201168"/>
           </a:xfrm>
           <a:prstGeom prst="rect">
@@ -8040,13 +7973,13 @@
       </p:sp>
       <p:sp>
         <p:nvSpPr>
-          <p:cNvPr id="34" name="Text 32"/>
-          <p:cNvSpPr/>
-          <p:nvPr/>
-        </p:nvSpPr>
-        <p:spPr>
-          <a:xfrm>
-            <a:off x="7159752" y="3690823"/>
+          <p:cNvPr id="32" name="Text 30"/>
+          <p:cNvSpPr/>
+          <p:nvPr/>
+        </p:nvSpPr>
+        <p:spPr>
+          <a:xfrm>
+            <a:off x="7159752" y="3593531"/>
             <a:ext cx="3968496" cy="877824"/>
           </a:xfrm>
           <a:prstGeom prst="rect">
@@ -8345,7 +8278,7 @@
         </p:nvSpPr>
         <p:spPr>
           <a:xfrm>
-            <a:off x="10954512" y="402336"/>
+            <a:off x="10899648" y="475488"/>
             <a:ext cx="402336" cy="402336"/>
           </a:xfrm>
           <a:prstGeom prst="ellipse">
@@ -8367,7 +8300,7 @@
         </p:nvSpPr>
         <p:spPr>
           <a:xfrm>
-            <a:off x="11098530" y="345186"/>
+            <a:off x="11043666" y="418338"/>
             <a:ext cx="114300" cy="114300"/>
           </a:xfrm>
           <a:prstGeom prst="ellipse">
@@ -8392,7 +8325,7 @@
         </p:nvSpPr>
         <p:spPr>
           <a:xfrm>
-            <a:off x="11299698" y="546354"/>
+            <a:off x="11244834" y="619506"/>
             <a:ext cx="114300" cy="114300"/>
           </a:xfrm>
           <a:prstGeom prst="ellipse">
@@ -8417,7 +8350,7 @@
         </p:nvSpPr>
         <p:spPr>
           <a:xfrm>
-            <a:off x="11098530" y="747522"/>
+            <a:off x="11043666" y="820674"/>
             <a:ext cx="114300" cy="114300"/>
           </a:xfrm>
           <a:prstGeom prst="ellipse">
@@ -8442,7 +8375,7 @@
         </p:nvSpPr>
         <p:spPr>
           <a:xfrm>
-            <a:off x="10897362" y="546354"/>
+            <a:off x="10842498" y="619506"/>
             <a:ext cx="114300" cy="114300"/>
           </a:xfrm>
           <a:prstGeom prst="ellipse">
@@ -8467,8 +8400,8 @@
         </p:nvSpPr>
         <p:spPr>
           <a:xfrm>
-            <a:off x="9189720" y="841248"/>
-            <a:ext cx="2194560" cy="164592"/>
+            <a:off x="10775290" y="932688"/>
+            <a:ext cx="608990" cy="164592"/>
           </a:xfrm>
           <a:prstGeom prst="rect">
             <a:avLst/>
@@ -8845,7 +8778,7 @@
         </p:nvSpPr>
         <p:spPr>
           <a:xfrm>
-            <a:off x="10954512" y="402336"/>
+            <a:off x="10899648" y="475488"/>
             <a:ext cx="402336" cy="402336"/>
           </a:xfrm>
           <a:prstGeom prst="ellipse">
@@ -8867,7 +8800,7 @@
         </p:nvSpPr>
         <p:spPr>
           <a:xfrm>
-            <a:off x="11098530" y="345186"/>
+            <a:off x="11043666" y="418338"/>
             <a:ext cx="114300" cy="114300"/>
           </a:xfrm>
           <a:prstGeom prst="ellipse">
@@ -8892,7 +8825,7 @@
         </p:nvSpPr>
         <p:spPr>
           <a:xfrm>
-            <a:off x="11299698" y="546354"/>
+            <a:off x="11244834" y="619506"/>
             <a:ext cx="114300" cy="114300"/>
           </a:xfrm>
           <a:prstGeom prst="ellipse">
@@ -8917,7 +8850,7 @@
         </p:nvSpPr>
         <p:spPr>
           <a:xfrm>
-            <a:off x="11098530" y="747522"/>
+            <a:off x="11043666" y="820674"/>
             <a:ext cx="114300" cy="114300"/>
           </a:xfrm>
           <a:prstGeom prst="ellipse">
@@ -8942,7 +8875,7 @@
         </p:nvSpPr>
         <p:spPr>
           <a:xfrm>
-            <a:off x="10897362" y="546354"/>
+            <a:off x="10842498" y="619506"/>
             <a:ext cx="114300" cy="114300"/>
           </a:xfrm>
           <a:prstGeom prst="ellipse">
@@ -8967,8 +8900,8 @@
         </p:nvSpPr>
         <p:spPr>
           <a:xfrm>
-            <a:off x="9189720" y="841248"/>
-            <a:ext cx="2194560" cy="164592"/>
+            <a:off x="10204704" y="932688"/>
+            <a:ext cx="1179576" cy="164592"/>
           </a:xfrm>
           <a:prstGeom prst="rect">
             <a:avLst/>
@@ -9320,7 +9253,7 @@
         </p:nvSpPr>
         <p:spPr>
           <a:xfrm>
-            <a:off x="10954512" y="402336"/>
+            <a:off x="10899648" y="475488"/>
             <a:ext cx="402336" cy="402336"/>
           </a:xfrm>
           <a:prstGeom prst="ellipse">
@@ -9342,7 +9275,7 @@
         </p:nvSpPr>
         <p:spPr>
           <a:xfrm>
-            <a:off x="11098530" y="345186"/>
+            <a:off x="11043666" y="418338"/>
             <a:ext cx="114300" cy="114300"/>
           </a:xfrm>
           <a:prstGeom prst="ellipse">
@@ -9367,7 +9300,7 @@
         </p:nvSpPr>
         <p:spPr>
           <a:xfrm>
-            <a:off x="11299698" y="546354"/>
+            <a:off x="11244834" y="619506"/>
             <a:ext cx="114300" cy="114300"/>
           </a:xfrm>
           <a:prstGeom prst="ellipse">
@@ -9392,7 +9325,7 @@
         </p:nvSpPr>
         <p:spPr>
           <a:xfrm>
-            <a:off x="11098530" y="747522"/>
+            <a:off x="11043666" y="820674"/>
             <a:ext cx="114300" cy="114300"/>
           </a:xfrm>
           <a:prstGeom prst="ellipse">
@@ -9417,7 +9350,7 @@
         </p:nvSpPr>
         <p:spPr>
           <a:xfrm>
-            <a:off x="10897362" y="546354"/>
+            <a:off x="10842498" y="619506"/>
             <a:ext cx="114300" cy="114300"/>
           </a:xfrm>
           <a:prstGeom prst="ellipse">
@@ -9442,8 +9375,8 @@
         </p:nvSpPr>
         <p:spPr>
           <a:xfrm>
-            <a:off x="9189720" y="841248"/>
-            <a:ext cx="2194560" cy="164592"/>
+            <a:off x="10204704" y="932688"/>
+            <a:ext cx="1179576" cy="164592"/>
           </a:xfrm>
           <a:prstGeom prst="rect">
             <a:avLst/>
@@ -9521,7 +9454,7 @@
         <p:spPr>
           <a:xfrm>
             <a:off x="813816" y="841248"/>
-            <a:ext cx="10570464" cy="751027"/>
+            <a:ext cx="9418320" cy="653735"/>
           </a:xfrm>
           <a:prstGeom prst="rect">
             <a:avLst/>
@@ -9540,7 +9473,7 @@
               <a:buNone/>
             </a:pPr>
             <a:r>
-              <a:rPr lang="en-US" sz="4000" b="1" dirty="0">
+              <a:rPr lang="en-US" sz="3400" b="1" dirty="0">
                 <a:solidFill>
                   <a:srgbClr val="14213D"/>
                 </a:solidFill>
@@ -9550,7 +9483,7 @@
               </a:rPr>
               <a:t>This is the document. She writes it.</a:t>
             </a:r>
-            <a:endParaRPr lang="en-US" sz="4000" dirty="0"/>
+            <a:endParaRPr lang="en-US" sz="3400" dirty="0"/>
           </a:p>
         </p:txBody>
       </p:sp>
@@ -9562,8 +9495,8 @@
         </p:nvSpPr>
         <p:spPr>
           <a:xfrm>
-            <a:off x="813816" y="1775155"/>
-            <a:ext cx="6949440" cy="1988820"/>
+            <a:off x="813816" y="1677863"/>
+            <a:ext cx="7315200" cy="1988820"/>
           </a:xfrm>
           <a:prstGeom prst="rect">
             <a:avLst/>
@@ -9582,8 +9515,8 @@
         </p:nvSpPr>
         <p:spPr>
           <a:xfrm>
-            <a:off x="1069848" y="1948891"/>
-            <a:ext cx="6437376" cy="201168"/>
+            <a:off x="1069848" y="1851599"/>
+            <a:ext cx="6803136" cy="201168"/>
           </a:xfrm>
           <a:prstGeom prst="rect">
             <a:avLst/>
@@ -9621,8 +9554,8 @@
         </p:nvSpPr>
         <p:spPr>
           <a:xfrm>
-            <a:off x="1069848" y="2232355"/>
-            <a:ext cx="6437376" cy="1440180"/>
+            <a:off x="1069848" y="2135063"/>
+            <a:ext cx="6803136" cy="1440180"/>
           </a:xfrm>
           <a:prstGeom prst="rect">
             <a:avLst/>
@@ -9772,8 +9705,8 @@
         </p:nvSpPr>
         <p:spPr>
           <a:xfrm>
-            <a:off x="813816" y="3983431"/>
-            <a:ext cx="6949440" cy="864108"/>
+            <a:off x="813816" y="3886139"/>
+            <a:ext cx="7315200" cy="864108"/>
           </a:xfrm>
           <a:prstGeom prst="rect">
             <a:avLst/>
@@ -9792,8 +9725,8 @@
         </p:nvSpPr>
         <p:spPr>
           <a:xfrm>
-            <a:off x="1069848" y="4157167"/>
-            <a:ext cx="6437376" cy="201168"/>
+            <a:off x="1069848" y="4059875"/>
+            <a:ext cx="6803136" cy="201168"/>
           </a:xfrm>
           <a:prstGeom prst="rect">
             <a:avLst/>
@@ -9831,8 +9764,8 @@
         </p:nvSpPr>
         <p:spPr>
           <a:xfrm>
-            <a:off x="1069848" y="4440631"/>
-            <a:ext cx="6437376" cy="315468"/>
+            <a:off x="1069848" y="4343339"/>
+            <a:ext cx="6803136" cy="315468"/>
           </a:xfrm>
           <a:prstGeom prst="rect">
             <a:avLst/>
@@ -9873,8 +9806,8 @@
         </p:nvSpPr>
         <p:spPr>
           <a:xfrm>
-            <a:off x="8129016" y="1811731"/>
-            <a:ext cx="3255264" cy="299466"/>
+            <a:off x="8494776" y="1714439"/>
+            <a:ext cx="2889504" cy="299466"/>
           </a:xfrm>
           <a:prstGeom prst="rect">
             <a:avLst/>
@@ -9912,7 +9845,7 @@
         </p:nvSpPr>
         <p:spPr>
           <a:xfrm rot="2700000">
-            <a:off x="8129016" y="2232355"/>
+            <a:off x="8494776" y="2135063"/>
             <a:ext cx="100584" cy="100584"/>
           </a:xfrm>
           <a:prstGeom prst="rect">
@@ -9937,8 +9870,8 @@
         </p:nvSpPr>
         <p:spPr>
           <a:xfrm>
-            <a:off x="8439912" y="2177491"/>
-            <a:ext cx="2944368" cy="315468"/>
+            <a:off x="8805672" y="2080199"/>
+            <a:ext cx="2578608" cy="315468"/>
           </a:xfrm>
           <a:prstGeom prst="rect">
             <a:avLst/>
@@ -9976,8 +9909,8 @@
         </p:nvSpPr>
         <p:spPr>
           <a:xfrm>
-            <a:off x="8439912" y="2492959"/>
-            <a:ext cx="2944368" cy="283464"/>
+            <a:off x="8805672" y="2395667"/>
+            <a:ext cx="2578608" cy="283464"/>
           </a:xfrm>
           <a:prstGeom prst="rect">
             <a:avLst/>
@@ -10015,7 +9948,7 @@
         </p:nvSpPr>
         <p:spPr>
           <a:xfrm rot="2700000">
-            <a:off x="8129016" y="2941015"/>
+            <a:off x="8494776" y="2843723"/>
             <a:ext cx="100584" cy="100584"/>
           </a:xfrm>
           <a:prstGeom prst="rect">
@@ -10040,8 +9973,8 @@
         </p:nvSpPr>
         <p:spPr>
           <a:xfrm>
-            <a:off x="8439912" y="2886151"/>
-            <a:ext cx="2944368" cy="315468"/>
+            <a:off x="8805672" y="2788859"/>
+            <a:ext cx="2578608" cy="315468"/>
           </a:xfrm>
           <a:prstGeom prst="rect">
             <a:avLst/>
@@ -10079,8 +10012,8 @@
         </p:nvSpPr>
         <p:spPr>
           <a:xfrm>
-            <a:off x="8439912" y="3201619"/>
-            <a:ext cx="2944368" cy="283464"/>
+            <a:off x="8805672" y="3104327"/>
+            <a:ext cx="2578608" cy="283464"/>
           </a:xfrm>
           <a:prstGeom prst="rect">
             <a:avLst/>
@@ -10118,7 +10051,7 @@
         </p:nvSpPr>
         <p:spPr>
           <a:xfrm rot="2700000">
-            <a:off x="8129016" y="3649675"/>
+            <a:off x="8494776" y="3552383"/>
             <a:ext cx="100584" cy="100584"/>
           </a:xfrm>
           <a:prstGeom prst="rect">
@@ -10143,8 +10076,8 @@
         </p:nvSpPr>
         <p:spPr>
           <a:xfrm>
-            <a:off x="8439912" y="3594811"/>
-            <a:ext cx="2944368" cy="315468"/>
+            <a:off x="8805672" y="3497519"/>
+            <a:ext cx="2578608" cy="315468"/>
           </a:xfrm>
           <a:prstGeom prst="rect">
             <a:avLst/>
@@ -10182,8 +10115,8 @@
         </p:nvSpPr>
         <p:spPr>
           <a:xfrm>
-            <a:off x="8439912" y="3910279"/>
-            <a:ext cx="2944368" cy="283464"/>
+            <a:off x="8805672" y="3812987"/>
+            <a:ext cx="2578608" cy="283464"/>
           </a:xfrm>
           <a:prstGeom prst="rect">
             <a:avLst/>
@@ -10221,7 +10154,7 @@
         </p:nvSpPr>
         <p:spPr>
           <a:xfrm rot="2700000">
-            <a:off x="8129016" y="4358335"/>
+            <a:off x="8494776" y="4261043"/>
             <a:ext cx="100584" cy="100584"/>
           </a:xfrm>
           <a:prstGeom prst="rect">
@@ -10246,8 +10179,8 @@
         </p:nvSpPr>
         <p:spPr>
           <a:xfrm>
-            <a:off x="8439912" y="4303471"/>
-            <a:ext cx="2944368" cy="315468"/>
+            <a:off x="8805672" y="4206179"/>
+            <a:ext cx="2578608" cy="315468"/>
           </a:xfrm>
           <a:prstGeom prst="rect">
             <a:avLst/>
@@ -10285,8 +10218,8 @@
         </p:nvSpPr>
         <p:spPr>
           <a:xfrm>
-            <a:off x="8439912" y="4618939"/>
-            <a:ext cx="2944368" cy="283464"/>
+            <a:off x="8805672" y="4521647"/>
+            <a:ext cx="2578608" cy="283464"/>
           </a:xfrm>
           <a:prstGeom prst="rect">
             <a:avLst/>
@@ -10521,7 +10454,7 @@
         </p:nvSpPr>
         <p:spPr>
           <a:xfrm>
-            <a:off x="10954512" y="402336"/>
+            <a:off x="10899648" y="475488"/>
             <a:ext cx="402336" cy="402336"/>
           </a:xfrm>
           <a:prstGeom prst="ellipse">
@@ -10543,7 +10476,7 @@
         </p:nvSpPr>
         <p:spPr>
           <a:xfrm>
-            <a:off x="11098530" y="345186"/>
+            <a:off x="11043666" y="418338"/>
             <a:ext cx="114300" cy="114300"/>
           </a:xfrm>
           <a:prstGeom prst="ellipse">
@@ -10568,7 +10501,7 @@
         </p:nvSpPr>
         <p:spPr>
           <a:xfrm>
-            <a:off x="11299698" y="546354"/>
+            <a:off x="11244834" y="619506"/>
             <a:ext cx="114300" cy="114300"/>
           </a:xfrm>
           <a:prstGeom prst="ellipse">
@@ -10593,7 +10526,7 @@
         </p:nvSpPr>
         <p:spPr>
           <a:xfrm>
-            <a:off x="11098530" y="747522"/>
+            <a:off x="11043666" y="820674"/>
             <a:ext cx="114300" cy="114300"/>
           </a:xfrm>
           <a:prstGeom prst="ellipse">
@@ -10618,7 +10551,7 @@
         </p:nvSpPr>
         <p:spPr>
           <a:xfrm>
-            <a:off x="10897362" y="546354"/>
+            <a:off x="10842498" y="619506"/>
             <a:ext cx="114300" cy="114300"/>
           </a:xfrm>
           <a:prstGeom prst="ellipse">
@@ -10643,8 +10576,8 @@
         </p:nvSpPr>
         <p:spPr>
           <a:xfrm>
-            <a:off x="9189720" y="841248"/>
-            <a:ext cx="2194560" cy="164592"/>
+            <a:off x="10204704" y="932688"/>
+            <a:ext cx="1179576" cy="164592"/>
           </a:xfrm>
           <a:prstGeom prst="rect">
             <a:avLst/>
@@ -11097,7 +11030,7 @@
         </p:nvSpPr>
         <p:spPr>
           <a:xfrm>
-            <a:off x="10954512" y="402336"/>
+            <a:off x="10899648" y="475488"/>
             <a:ext cx="402336" cy="402336"/>
           </a:xfrm>
           <a:prstGeom prst="ellipse">
@@ -11119,7 +11052,7 @@
         </p:nvSpPr>
         <p:spPr>
           <a:xfrm>
-            <a:off x="11098530" y="345186"/>
+            <a:off x="11043666" y="418338"/>
             <a:ext cx="114300" cy="114300"/>
           </a:xfrm>
           <a:prstGeom prst="ellipse">
@@ -11144,7 +11077,7 @@
         </p:nvSpPr>
         <p:spPr>
           <a:xfrm>
-            <a:off x="11299698" y="546354"/>
+            <a:off x="11244834" y="619506"/>
             <a:ext cx="114300" cy="114300"/>
           </a:xfrm>
           <a:prstGeom prst="ellipse">
@@ -11169,7 +11102,7 @@
         </p:nvSpPr>
         <p:spPr>
           <a:xfrm>
-            <a:off x="11098530" y="747522"/>
+            <a:off x="11043666" y="820674"/>
             <a:ext cx="114300" cy="114300"/>
           </a:xfrm>
           <a:prstGeom prst="ellipse">
@@ -11194,7 +11127,7 @@
         </p:nvSpPr>
         <p:spPr>
           <a:xfrm>
-            <a:off x="10897362" y="546354"/>
+            <a:off x="10842498" y="619506"/>
             <a:ext cx="114300" cy="114300"/>
           </a:xfrm>
           <a:prstGeom prst="ellipse">
@@ -11219,8 +11152,8 @@
         </p:nvSpPr>
         <p:spPr>
           <a:xfrm>
-            <a:off x="9189720" y="841248"/>
-            <a:ext cx="2194560" cy="164592"/>
+            <a:off x="9776765" y="932688"/>
+            <a:ext cx="1607515" cy="164592"/>
           </a:xfrm>
           <a:prstGeom prst="rect">
             <a:avLst/>
@@ -11572,7 +11505,7 @@
         </p:nvSpPr>
         <p:spPr>
           <a:xfrm>
-            <a:off x="10954512" y="402336"/>
+            <a:off x="10899648" y="475488"/>
             <a:ext cx="402336" cy="402336"/>
           </a:xfrm>
           <a:prstGeom prst="ellipse">
@@ -11594,7 +11527,7 @@
         </p:nvSpPr>
         <p:spPr>
           <a:xfrm>
-            <a:off x="11098530" y="345186"/>
+            <a:off x="11043666" y="418338"/>
             <a:ext cx="114300" cy="114300"/>
           </a:xfrm>
           <a:prstGeom prst="ellipse">
@@ -11619,7 +11552,7 @@
         </p:nvSpPr>
         <p:spPr>
           <a:xfrm>
-            <a:off x="11299698" y="546354"/>
+            <a:off x="11244834" y="619506"/>
             <a:ext cx="114300" cy="114300"/>
           </a:xfrm>
           <a:prstGeom prst="ellipse">
@@ -11644,7 +11577,7 @@
         </p:nvSpPr>
         <p:spPr>
           <a:xfrm>
-            <a:off x="11098530" y="747522"/>
+            <a:off x="11043666" y="820674"/>
             <a:ext cx="114300" cy="114300"/>
           </a:xfrm>
           <a:prstGeom prst="ellipse">
@@ -11669,7 +11602,7 @@
         </p:nvSpPr>
         <p:spPr>
           <a:xfrm>
-            <a:off x="10897362" y="546354"/>
+            <a:off x="10842498" y="619506"/>
             <a:ext cx="114300" cy="114300"/>
           </a:xfrm>
           <a:prstGeom prst="ellipse">
@@ -11694,8 +11627,8 @@
         </p:nvSpPr>
         <p:spPr>
           <a:xfrm>
-            <a:off x="9189720" y="841248"/>
-            <a:ext cx="2194560" cy="164592"/>
+            <a:off x="9776765" y="932688"/>
+            <a:ext cx="1607515" cy="164592"/>
           </a:xfrm>
           <a:prstGeom prst="rect">
             <a:avLst/>
@@ -11773,7 +11706,7 @@
         <p:spPr>
           <a:xfrm>
             <a:off x="813816" y="841248"/>
-            <a:ext cx="10570464" cy="751027"/>
+            <a:ext cx="9418320" cy="653735"/>
           </a:xfrm>
           <a:prstGeom prst="rect">
             <a:avLst/>
@@ -11792,7 +11725,7 @@
               <a:buNone/>
             </a:pPr>
             <a:r>
-              <a:rPr lang="en-US" sz="4000" b="1" dirty="0">
+              <a:rPr lang="en-US" sz="3400" b="1" dirty="0">
                 <a:solidFill>
                   <a:srgbClr val="14213D"/>
                 </a:solidFill>
@@ -11802,7 +11735,7 @@
               </a:rPr>
               <a:t>She writes her own playbook file.</a:t>
             </a:r>
-            <a:endParaRPr lang="en-US" sz="4000" dirty="0"/>
+            <a:endParaRPr lang="en-US" sz="3400" dirty="0"/>
           </a:p>
         </p:txBody>
       </p:sp>
@@ -11814,8 +11747,8 @@
         </p:nvSpPr>
         <p:spPr>
           <a:xfrm>
-            <a:off x="813816" y="1775155"/>
-            <a:ext cx="6949440" cy="2176272"/>
+            <a:off x="813816" y="1677863"/>
+            <a:ext cx="7315200" cy="2176272"/>
           </a:xfrm>
           <a:prstGeom prst="rect">
             <a:avLst/>
@@ -11834,8 +11767,8 @@
         </p:nvSpPr>
         <p:spPr>
           <a:xfrm>
-            <a:off x="1069848" y="1948891"/>
-            <a:ext cx="6437376" cy="201168"/>
+            <a:off x="1069848" y="1851599"/>
+            <a:ext cx="6803136" cy="201168"/>
           </a:xfrm>
           <a:prstGeom prst="rect">
             <a:avLst/>
@@ -11873,8 +11806,8 @@
         </p:nvSpPr>
         <p:spPr>
           <a:xfrm>
-            <a:off x="1069848" y="2232355"/>
-            <a:ext cx="6437376" cy="1627632"/>
+            <a:off x="1069848" y="2135063"/>
+            <a:ext cx="6803136" cy="1627632"/>
           </a:xfrm>
           <a:prstGeom prst="rect">
             <a:avLst/>
@@ -12055,8 +11988,8 @@
         </p:nvSpPr>
         <p:spPr>
           <a:xfrm>
-            <a:off x="813816" y="4170883"/>
-            <a:ext cx="6949440" cy="982980"/>
+            <a:off x="813816" y="4073591"/>
+            <a:ext cx="7315200" cy="982980"/>
           </a:xfrm>
           <a:prstGeom prst="rect">
             <a:avLst/>
@@ -12075,7 +12008,7 @@
         </p:nvSpPr>
         <p:spPr>
           <a:xfrm rot="2700000">
-            <a:off x="1051560" y="4486351"/>
+            <a:off x="1051560" y="4389059"/>
             <a:ext cx="100584" cy="100584"/>
           </a:xfrm>
           <a:prstGeom prst="rect">
@@ -12100,8 +12033,8 @@
         </p:nvSpPr>
         <p:spPr>
           <a:xfrm>
-            <a:off x="1362456" y="4408627"/>
-            <a:ext cx="6163056" cy="507492"/>
+            <a:off x="1362456" y="4311335"/>
+            <a:ext cx="6528816" cy="507492"/>
           </a:xfrm>
           <a:prstGeom prst="rect">
             <a:avLst/>
@@ -12142,8 +12075,8 @@
         </p:nvSpPr>
         <p:spPr>
           <a:xfrm>
-            <a:off x="8129016" y="1811731"/>
-            <a:ext cx="3255264" cy="299466"/>
+            <a:off x="8494776" y="1714439"/>
+            <a:ext cx="2889504" cy="299466"/>
           </a:xfrm>
           <a:prstGeom prst="rect">
             <a:avLst/>
@@ -12181,7 +12114,7 @@
         </p:nvSpPr>
         <p:spPr>
           <a:xfrm>
-            <a:off x="8129016" y="2241499"/>
+            <a:off x="8494776" y="2144207"/>
             <a:ext cx="365760" cy="347472"/>
           </a:xfrm>
           <a:prstGeom prst="rect">
@@ -12220,8 +12153,8 @@
         </p:nvSpPr>
         <p:spPr>
           <a:xfrm>
-            <a:off x="8586216" y="2268931"/>
-            <a:ext cx="2798064" cy="315468"/>
+            <a:off x="8951976" y="2171639"/>
+            <a:ext cx="2432304" cy="315468"/>
           </a:xfrm>
           <a:prstGeom prst="rect">
             <a:avLst/>
@@ -12262,7 +12195,7 @@
         </p:nvSpPr>
         <p:spPr>
           <a:xfrm>
-            <a:off x="8129016" y="2899867"/>
+            <a:off x="8494776" y="2802575"/>
             <a:ext cx="365760" cy="347472"/>
           </a:xfrm>
           <a:prstGeom prst="rect">
@@ -12301,8 +12234,8 @@
         </p:nvSpPr>
         <p:spPr>
           <a:xfrm>
-            <a:off x="8586216" y="2927299"/>
-            <a:ext cx="2798064" cy="539496"/>
+            <a:off x="8951976" y="2830007"/>
+            <a:ext cx="2432304" cy="539496"/>
           </a:xfrm>
           <a:prstGeom prst="rect">
             <a:avLst/>
@@ -12343,7 +12276,7 @@
         </p:nvSpPr>
         <p:spPr>
           <a:xfrm>
-            <a:off x="8129016" y="3750259"/>
+            <a:off x="8494776" y="3652967"/>
             <a:ext cx="365760" cy="347472"/>
           </a:xfrm>
           <a:prstGeom prst="rect">
@@ -12382,8 +12315,8 @@
         </p:nvSpPr>
         <p:spPr>
           <a:xfrm>
-            <a:off x="8586216" y="3777691"/>
-            <a:ext cx="2798064" cy="763524"/>
+            <a:off x="8951976" y="3680399"/>
+            <a:ext cx="2432304" cy="987552"/>
           </a:xfrm>
           <a:prstGeom prst="rect">
             <a:avLst/>
@@ -12621,7 +12554,7 @@
         </p:nvSpPr>
         <p:spPr>
           <a:xfrm>
-            <a:off x="10954512" y="402336"/>
+            <a:off x="10899648" y="475488"/>
             <a:ext cx="402336" cy="402336"/>
           </a:xfrm>
           <a:prstGeom prst="ellipse">
@@ -12643,7 +12576,7 @@
         </p:nvSpPr>
         <p:spPr>
           <a:xfrm>
-            <a:off x="11098530" y="345186"/>
+            <a:off x="11043666" y="418338"/>
             <a:ext cx="114300" cy="114300"/>
           </a:xfrm>
           <a:prstGeom prst="ellipse">
@@ -12668,7 +12601,7 @@
         </p:nvSpPr>
         <p:spPr>
           <a:xfrm>
-            <a:off x="11299698" y="546354"/>
+            <a:off x="11244834" y="619506"/>
             <a:ext cx="114300" cy="114300"/>
           </a:xfrm>
           <a:prstGeom prst="ellipse">
@@ -12693,7 +12626,7 @@
         </p:nvSpPr>
         <p:spPr>
           <a:xfrm>
-            <a:off x="11098530" y="747522"/>
+            <a:off x="11043666" y="820674"/>
             <a:ext cx="114300" cy="114300"/>
           </a:xfrm>
           <a:prstGeom prst="ellipse">
@@ -12718,7 +12651,7 @@
         </p:nvSpPr>
         <p:spPr>
           <a:xfrm>
-            <a:off x="10897362" y="546354"/>
+            <a:off x="10842498" y="619506"/>
             <a:ext cx="114300" cy="114300"/>
           </a:xfrm>
           <a:prstGeom prst="ellipse">
@@ -12743,8 +12676,8 @@
         </p:nvSpPr>
         <p:spPr>
           <a:xfrm>
-            <a:off x="9189720" y="841248"/>
-            <a:ext cx="2194560" cy="164592"/>
+            <a:off x="9776765" y="932688"/>
+            <a:ext cx="1607515" cy="164592"/>
           </a:xfrm>
           <a:prstGeom prst="rect">
             <a:avLst/>
@@ -12822,7 +12755,7 @@
         <p:spPr>
           <a:xfrm>
             <a:off x="813816" y="841248"/>
-            <a:ext cx="10570464" cy="751027"/>
+            <a:ext cx="9418320" cy="751027"/>
           </a:xfrm>
           <a:prstGeom prst="rect">
             <a:avLst/>
@@ -12864,7 +12797,7 @@
         <p:spPr>
           <a:xfrm>
             <a:off x="813816" y="1775155"/>
-            <a:ext cx="7132320" cy="2363724"/>
+            <a:ext cx="7315200" cy="2363724"/>
           </a:xfrm>
           <a:prstGeom prst="rect">
             <a:avLst/>
@@ -12884,7 +12817,7 @@
         <p:spPr>
           <a:xfrm>
             <a:off x="1069848" y="1948891"/>
-            <a:ext cx="6620256" cy="201168"/>
+            <a:ext cx="6803136" cy="201168"/>
           </a:xfrm>
           <a:prstGeom prst="rect">
             <a:avLst/>
@@ -12923,7 +12856,7 @@
         <p:spPr>
           <a:xfrm>
             <a:off x="1069848" y="2232355"/>
-            <a:ext cx="6620256" cy="1815084"/>
+            <a:ext cx="6803136" cy="1815084"/>
           </a:xfrm>
           <a:prstGeom prst="rect">
             <a:avLst/>
@@ -13124,7 +13057,7 @@
         </p:nvSpPr>
         <p:spPr>
           <a:xfrm>
-            <a:off x="8311896" y="1848307"/>
+            <a:off x="8494776" y="1848307"/>
             <a:ext cx="1097280" cy="420624"/>
           </a:xfrm>
           <a:prstGeom prst="rect">
@@ -13163,8 +13096,8 @@
         </p:nvSpPr>
         <p:spPr>
           <a:xfrm>
-            <a:off x="9464040" y="1848307"/>
-            <a:ext cx="1920240" cy="420624"/>
+            <a:off x="9646920" y="1848307"/>
+            <a:ext cx="1737360" cy="420624"/>
           </a:xfrm>
           <a:prstGeom prst="rect">
             <a:avLst/>
@@ -13202,7 +13135,7 @@
         </p:nvSpPr>
         <p:spPr>
           <a:xfrm>
-            <a:off x="8311896" y="2342083"/>
+            <a:off x="8494776" y="2342083"/>
             <a:ext cx="1097280" cy="420624"/>
           </a:xfrm>
           <a:prstGeom prst="rect">
@@ -13241,8 +13174,8 @@
         </p:nvSpPr>
         <p:spPr>
           <a:xfrm>
-            <a:off x="9464040" y="2342083"/>
-            <a:ext cx="1920240" cy="420624"/>
+            <a:off x="9646920" y="2342083"/>
+            <a:ext cx="1737360" cy="420624"/>
           </a:xfrm>
           <a:prstGeom prst="rect">
             <a:avLst/>
@@ -13280,7 +13213,7 @@
         </p:nvSpPr>
         <p:spPr>
           <a:xfrm>
-            <a:off x="8311896" y="2835859"/>
+            <a:off x="8494776" y="2835859"/>
             <a:ext cx="1097280" cy="420624"/>
           </a:xfrm>
           <a:prstGeom prst="rect">
@@ -13319,8 +13252,8 @@
         </p:nvSpPr>
         <p:spPr>
           <a:xfrm>
-            <a:off x="9464040" y="2835859"/>
-            <a:ext cx="1920240" cy="420624"/>
+            <a:off x="9646920" y="2835859"/>
+            <a:ext cx="1737360" cy="420624"/>
           </a:xfrm>
           <a:prstGeom prst="rect">
             <a:avLst/>
@@ -13358,8 +13291,8 @@
         </p:nvSpPr>
         <p:spPr>
           <a:xfrm>
-            <a:off x="8311896" y="3457651"/>
-            <a:ext cx="3072384" cy="1691640"/>
+            <a:off x="8494776" y="3457651"/>
+            <a:ext cx="2889504" cy="1691640"/>
           </a:xfrm>
           <a:prstGeom prst="rect">
             <a:avLst/>
@@ -13378,8 +13311,8 @@
         </p:nvSpPr>
         <p:spPr>
           <a:xfrm>
-            <a:off x="8531352" y="3677107"/>
-            <a:ext cx="2633472" cy="283464"/>
+            <a:off x="8714232" y="3677107"/>
+            <a:ext cx="2450592" cy="283464"/>
           </a:xfrm>
           <a:prstGeom prst="rect">
             <a:avLst/>
@@ -13417,7 +13350,7 @@
         </p:nvSpPr>
         <p:spPr>
           <a:xfrm rot="2700000">
-            <a:off x="8531352" y="4148023"/>
+            <a:off x="8714232" y="4148023"/>
             <a:ext cx="100584" cy="100584"/>
           </a:xfrm>
           <a:prstGeom prst="rect">
@@ -13442,8 +13375,8 @@
         </p:nvSpPr>
         <p:spPr>
           <a:xfrm>
-            <a:off x="8842248" y="4070299"/>
-            <a:ext cx="2322576" cy="859536"/>
+            <a:off x="9025128" y="4070299"/>
+            <a:ext cx="2139696" cy="859536"/>
           </a:xfrm>
           <a:prstGeom prst="rect">
             <a:avLst/>
@@ -13785,7 +13718,7 @@
         </p:nvSpPr>
         <p:spPr>
           <a:xfrm>
-            <a:off x="10954512" y="402336"/>
+            <a:off x="10899648" y="475488"/>
             <a:ext cx="402336" cy="402336"/>
           </a:xfrm>
           <a:prstGeom prst="ellipse">
@@ -13807,7 +13740,7 @@
         </p:nvSpPr>
         <p:spPr>
           <a:xfrm>
-            <a:off x="11098530" y="345186"/>
+            <a:off x="11043666" y="418338"/>
             <a:ext cx="114300" cy="114300"/>
           </a:xfrm>
           <a:prstGeom prst="ellipse">
@@ -13832,7 +13765,7 @@
         </p:nvSpPr>
         <p:spPr>
           <a:xfrm>
-            <a:off x="11299698" y="546354"/>
+            <a:off x="11244834" y="619506"/>
             <a:ext cx="114300" cy="114300"/>
           </a:xfrm>
           <a:prstGeom prst="ellipse">
@@ -13857,7 +13790,7 @@
         </p:nvSpPr>
         <p:spPr>
           <a:xfrm>
-            <a:off x="11098530" y="747522"/>
+            <a:off x="11043666" y="820674"/>
             <a:ext cx="114300" cy="114300"/>
           </a:xfrm>
           <a:prstGeom prst="ellipse">
@@ -13882,7 +13815,7 @@
         </p:nvSpPr>
         <p:spPr>
           <a:xfrm>
-            <a:off x="10897362" y="546354"/>
+            <a:off x="10842498" y="619506"/>
             <a:ext cx="114300" cy="114300"/>
           </a:xfrm>
           <a:prstGeom prst="ellipse">
@@ -13907,8 +13840,8 @@
         </p:nvSpPr>
         <p:spPr>
           <a:xfrm>
-            <a:off x="9189720" y="841248"/>
-            <a:ext cx="2194560" cy="164592"/>
+            <a:off x="9776765" y="932688"/>
+            <a:ext cx="1607515" cy="164592"/>
           </a:xfrm>
           <a:prstGeom prst="rect">
             <a:avLst/>
@@ -14344,7 +14277,7 @@
         </p:nvSpPr>
         <p:spPr>
           <a:xfrm>
-            <a:off x="10954512" y="402336"/>
+            <a:off x="10899648" y="475488"/>
             <a:ext cx="402336" cy="402336"/>
           </a:xfrm>
           <a:prstGeom prst="ellipse">
@@ -14366,7 +14299,7 @@
         </p:nvSpPr>
         <p:spPr>
           <a:xfrm>
-            <a:off x="11098530" y="345186"/>
+            <a:off x="11043666" y="418338"/>
             <a:ext cx="114300" cy="114300"/>
           </a:xfrm>
           <a:prstGeom prst="ellipse">
@@ -14391,7 +14324,7 @@
         </p:nvSpPr>
         <p:spPr>
           <a:xfrm>
-            <a:off x="11299698" y="546354"/>
+            <a:off x="11244834" y="619506"/>
             <a:ext cx="114300" cy="114300"/>
           </a:xfrm>
           <a:prstGeom prst="ellipse">
@@ -14416,7 +14349,7 @@
         </p:nvSpPr>
         <p:spPr>
           <a:xfrm>
-            <a:off x="11098530" y="747522"/>
+            <a:off x="11043666" y="820674"/>
             <a:ext cx="114300" cy="114300"/>
           </a:xfrm>
           <a:prstGeom prst="ellipse">
@@ -14441,7 +14374,7 @@
         </p:nvSpPr>
         <p:spPr>
           <a:xfrm>
-            <a:off x="10897362" y="546354"/>
+            <a:off x="10842498" y="619506"/>
             <a:ext cx="114300" cy="114300"/>
           </a:xfrm>
           <a:prstGeom prst="ellipse">
@@ -14466,8 +14399,8 @@
         </p:nvSpPr>
         <p:spPr>
           <a:xfrm>
-            <a:off x="9189720" y="841248"/>
-            <a:ext cx="2194560" cy="164592"/>
+            <a:off x="9063533" y="932688"/>
+            <a:ext cx="2320747" cy="164592"/>
           </a:xfrm>
           <a:prstGeom prst="rect">
             <a:avLst/>
@@ -14819,7 +14752,7 @@
         </p:nvSpPr>
         <p:spPr>
           <a:xfrm>
-            <a:off x="10954512" y="402336"/>
+            <a:off x="10899648" y="475488"/>
             <a:ext cx="402336" cy="402336"/>
           </a:xfrm>
           <a:prstGeom prst="ellipse">
@@ -14841,7 +14774,7 @@
         </p:nvSpPr>
         <p:spPr>
           <a:xfrm>
-            <a:off x="11098530" y="345186"/>
+            <a:off x="11043666" y="418338"/>
             <a:ext cx="114300" cy="114300"/>
           </a:xfrm>
           <a:prstGeom prst="ellipse">
@@ -14866,7 +14799,7 @@
         </p:nvSpPr>
         <p:spPr>
           <a:xfrm>
-            <a:off x="11299698" y="546354"/>
+            <a:off x="11244834" y="619506"/>
             <a:ext cx="114300" cy="114300"/>
           </a:xfrm>
           <a:prstGeom prst="ellipse">
@@ -14891,7 +14824,7 @@
         </p:nvSpPr>
         <p:spPr>
           <a:xfrm>
-            <a:off x="11098530" y="747522"/>
+            <a:off x="11043666" y="820674"/>
             <a:ext cx="114300" cy="114300"/>
           </a:xfrm>
           <a:prstGeom prst="ellipse">
@@ -14916,7 +14849,7 @@
         </p:nvSpPr>
         <p:spPr>
           <a:xfrm>
-            <a:off x="10897362" y="546354"/>
+            <a:off x="10842498" y="619506"/>
             <a:ext cx="114300" cy="114300"/>
           </a:xfrm>
           <a:prstGeom prst="ellipse">
@@ -14941,8 +14874,8 @@
         </p:nvSpPr>
         <p:spPr>
           <a:xfrm>
-            <a:off x="9189720" y="841248"/>
-            <a:ext cx="2194560" cy="164592"/>
+            <a:off x="9063533" y="932688"/>
+            <a:ext cx="2320747" cy="164592"/>
           </a:xfrm>
           <a:prstGeom prst="rect">
             <a:avLst/>
@@ -15020,7 +14953,7 @@
         <p:spPr>
           <a:xfrm>
             <a:off x="813816" y="841248"/>
-            <a:ext cx="10570464" cy="751027"/>
+            <a:ext cx="9418320" cy="751027"/>
           </a:xfrm>
           <a:prstGeom prst="rect">
             <a:avLst/>
@@ -15463,7 +15396,7 @@
         <p:spPr>
           <a:xfrm>
             <a:off x="8494776" y="1775155"/>
-            <a:ext cx="2889504" cy="1792224"/>
+            <a:ext cx="2889504" cy="1755648"/>
           </a:xfrm>
           <a:prstGeom prst="rect">
             <a:avLst/>
@@ -15482,8 +15415,8 @@
         </p:nvSpPr>
         <p:spPr>
           <a:xfrm>
-            <a:off x="8695944" y="1976323"/>
-            <a:ext cx="2487168" cy="283464"/>
+            <a:off x="8677656" y="1958035"/>
+            <a:ext cx="2523744" cy="283464"/>
           </a:xfrm>
           <a:prstGeom prst="rect">
             <a:avLst/>
@@ -15521,7 +15454,7 @@
         </p:nvSpPr>
         <p:spPr>
           <a:xfrm rot="2700000">
-            <a:off x="8695944" y="2447239"/>
+            <a:off x="8677656" y="2428951"/>
             <a:ext cx="100584" cy="100584"/>
           </a:xfrm>
           <a:prstGeom prst="rect">
@@ -15546,8 +15479,8 @@
         </p:nvSpPr>
         <p:spPr>
           <a:xfrm>
-            <a:off x="9006840" y="2369515"/>
-            <a:ext cx="2176272" cy="283464"/>
+            <a:off x="8988552" y="2351227"/>
+            <a:ext cx="2212848" cy="283464"/>
           </a:xfrm>
           <a:prstGeom prst="rect">
             <a:avLst/>
@@ -15588,7 +15521,7 @@
         </p:nvSpPr>
         <p:spPr>
           <a:xfrm rot="2700000">
-            <a:off x="8695944" y="2803855"/>
+            <a:off x="8677656" y="2785567"/>
             <a:ext cx="100584" cy="100584"/>
           </a:xfrm>
           <a:prstGeom prst="rect">
@@ -15613,8 +15546,8 @@
         </p:nvSpPr>
         <p:spPr>
           <a:xfrm>
-            <a:off x="9006840" y="2726131"/>
-            <a:ext cx="2176272" cy="283464"/>
+            <a:off x="8988552" y="2707843"/>
+            <a:ext cx="2212848" cy="283464"/>
           </a:xfrm>
           <a:prstGeom prst="rect">
             <a:avLst/>
@@ -15655,7 +15588,7 @@
         </p:nvSpPr>
         <p:spPr>
           <a:xfrm rot="2700000">
-            <a:off x="8695944" y="3160471"/>
+            <a:off x="8677656" y="3142183"/>
             <a:ext cx="100584" cy="100584"/>
           </a:xfrm>
           <a:prstGeom prst="rect">
@@ -15680,8 +15613,8 @@
         </p:nvSpPr>
         <p:spPr>
           <a:xfrm>
-            <a:off x="9006840" y="3082747"/>
-            <a:ext cx="2176272" cy="283464"/>
+            <a:off x="8988552" y="3064459"/>
+            <a:ext cx="2212848" cy="283464"/>
           </a:xfrm>
           <a:prstGeom prst="rect">
             <a:avLst/>
@@ -15722,8 +15655,8 @@
         </p:nvSpPr>
         <p:spPr>
           <a:xfrm>
-            <a:off x="8494776" y="3713683"/>
-            <a:ext cx="2889504" cy="1792224"/>
+            <a:off x="8494776" y="3805123"/>
+            <a:ext cx="2889504" cy="1755648"/>
           </a:xfrm>
           <a:prstGeom prst="rect">
             <a:avLst/>
@@ -15742,8 +15675,8 @@
         </p:nvSpPr>
         <p:spPr>
           <a:xfrm>
-            <a:off x="8695944" y="3914851"/>
-            <a:ext cx="2487168" cy="283464"/>
+            <a:off x="8677656" y="3988003"/>
+            <a:ext cx="2523744" cy="283464"/>
           </a:xfrm>
           <a:prstGeom prst="rect">
             <a:avLst/>
@@ -15781,7 +15714,7 @@
         </p:nvSpPr>
         <p:spPr>
           <a:xfrm rot="2700000">
-            <a:off x="8695944" y="4385767"/>
+            <a:off x="8677656" y="4458919"/>
             <a:ext cx="100584" cy="100584"/>
           </a:xfrm>
           <a:prstGeom prst="rect">
@@ -15806,8 +15739,8 @@
         </p:nvSpPr>
         <p:spPr>
           <a:xfrm>
-            <a:off x="9006840" y="4308043"/>
-            <a:ext cx="2176272" cy="283464"/>
+            <a:off x="8988552" y="4381195"/>
+            <a:ext cx="2212848" cy="283464"/>
           </a:xfrm>
           <a:prstGeom prst="rect">
             <a:avLst/>
@@ -15848,7 +15781,7 @@
         </p:nvSpPr>
         <p:spPr>
           <a:xfrm rot="2700000">
-            <a:off x="8695944" y="4742383"/>
+            <a:off x="8677656" y="4815535"/>
             <a:ext cx="100584" cy="100584"/>
           </a:xfrm>
           <a:prstGeom prst="rect">
@@ -15873,8 +15806,8 @@
         </p:nvSpPr>
         <p:spPr>
           <a:xfrm>
-            <a:off x="9006840" y="4664659"/>
-            <a:ext cx="2176272" cy="283464"/>
+            <a:off x="8988552" y="4737811"/>
+            <a:ext cx="2212848" cy="283464"/>
           </a:xfrm>
           <a:prstGeom prst="rect">
             <a:avLst/>
@@ -15915,7 +15848,7 @@
         </p:nvSpPr>
         <p:spPr>
           <a:xfrm rot="2700000">
-            <a:off x="8695944" y="5098999"/>
+            <a:off x="8677656" y="5172151"/>
             <a:ext cx="100584" cy="100584"/>
           </a:xfrm>
           <a:prstGeom prst="rect">
@@ -15940,8 +15873,8 @@
         </p:nvSpPr>
         <p:spPr>
           <a:xfrm>
-            <a:off x="9006840" y="5021275"/>
-            <a:ext cx="2176272" cy="283464"/>
+            <a:off x="8988552" y="5094427"/>
+            <a:ext cx="2212848" cy="283464"/>
           </a:xfrm>
           <a:prstGeom prst="rect">
             <a:avLst/>
@@ -16179,7 +16112,7 @@
         </p:nvSpPr>
         <p:spPr>
           <a:xfrm>
-            <a:off x="10954512" y="402336"/>
+            <a:off x="10899648" y="475488"/>
             <a:ext cx="402336" cy="402336"/>
           </a:xfrm>
           <a:prstGeom prst="ellipse">
@@ -16201,7 +16134,7 @@
         </p:nvSpPr>
         <p:spPr>
           <a:xfrm>
-            <a:off x="11098530" y="345186"/>
+            <a:off x="11043666" y="418338"/>
             <a:ext cx="114300" cy="114300"/>
           </a:xfrm>
           <a:prstGeom prst="ellipse">
@@ -16226,7 +16159,7 @@
         </p:nvSpPr>
         <p:spPr>
           <a:xfrm>
-            <a:off x="11299698" y="546354"/>
+            <a:off x="11244834" y="619506"/>
             <a:ext cx="114300" cy="114300"/>
           </a:xfrm>
           <a:prstGeom prst="ellipse">
@@ -16251,7 +16184,7 @@
         </p:nvSpPr>
         <p:spPr>
           <a:xfrm>
-            <a:off x="11098530" y="747522"/>
+            <a:off x="11043666" y="820674"/>
             <a:ext cx="114300" cy="114300"/>
           </a:xfrm>
           <a:prstGeom prst="ellipse">
@@ -16276,7 +16209,7 @@
         </p:nvSpPr>
         <p:spPr>
           <a:xfrm>
-            <a:off x="10897362" y="546354"/>
+            <a:off x="10842498" y="619506"/>
             <a:ext cx="114300" cy="114300"/>
           </a:xfrm>
           <a:prstGeom prst="ellipse">
@@ -16301,8 +16234,8 @@
         </p:nvSpPr>
         <p:spPr>
           <a:xfrm>
-            <a:off x="9189720" y="841248"/>
-            <a:ext cx="2194560" cy="164592"/>
+            <a:off x="9990734" y="932688"/>
+            <a:ext cx="1393546" cy="164592"/>
           </a:xfrm>
           <a:prstGeom prst="rect">
             <a:avLst/>
@@ -17157,9 +17090,9 @@
           <p:nvPr/>
         </p:nvSpPr>
         <p:spPr>
-          <a:xfrm rot="2700000">
-            <a:off x="3540873" y="2650224"/>
-            <a:ext cx="118872" cy="118872"/>
+          <a:xfrm rot="8100000">
+            <a:off x="3552760" y="2644281"/>
+            <a:ext cx="95098" cy="130759"/>
           </a:xfrm>
           <a:prstGeom prst="triangle">
             <a:avLst/>
@@ -17177,9 +17110,9 @@
           <p:nvPr/>
         </p:nvSpPr>
         <p:spPr>
-          <a:xfrm rot="8100000">
-            <a:off x="3540873" y="4071835"/>
-            <a:ext cx="118872" cy="118872"/>
+          <a:xfrm rot="13500000">
+            <a:off x="3552760" y="4065891"/>
+            <a:ext cx="95098" cy="130759"/>
           </a:xfrm>
           <a:prstGeom prst="triangle">
             <a:avLst/>
@@ -17197,9 +17130,9 @@
           <p:nvPr/>
         </p:nvSpPr>
         <p:spPr>
-          <a:xfrm rot="13500000">
-            <a:off x="2119263" y="4071835"/>
-            <a:ext cx="118872" cy="118872"/>
+          <a:xfrm rot="18900000">
+            <a:off x="2131150" y="4065891"/>
+            <a:ext cx="95098" cy="130759"/>
           </a:xfrm>
           <a:prstGeom prst="triangle">
             <a:avLst/>
@@ -17217,9 +17150,9 @@
           <p:nvPr/>
         </p:nvSpPr>
         <p:spPr>
-          <a:xfrm rot="18900000">
-            <a:off x="2119263" y="2650224"/>
-            <a:ext cx="118872" cy="118872"/>
+          <a:xfrm rot="2700000">
+            <a:off x="2131150" y="2644281"/>
+            <a:ext cx="95098" cy="130759"/>
           </a:xfrm>
           <a:prstGeom prst="triangle">
             <a:avLst/>
@@ -21688,8 +21621,8 @@
         </p:nvSpPr>
         <p:spPr>
           <a:xfrm>
-            <a:off x="1249528" y="914400"/>
-            <a:ext cx="9692640" cy="1529364"/>
+            <a:off x="1249528" y="822960"/>
+            <a:ext cx="9692640" cy="1399642"/>
           </a:xfrm>
           <a:prstGeom prst="rect">
             <a:avLst/>
@@ -21705,7 +21638,7 @@
               <a:buNone/>
             </a:pPr>
             <a:r>
-              <a:rPr lang="en-US" sz="4400" b="1" dirty="0">
+              <a:rPr lang="en-US" sz="4000" b="1" dirty="0">
                 <a:solidFill>
                   <a:srgbClr val="14213D"/>
                 </a:solidFill>
@@ -21715,7 +21648,7 @@
               </a:rPr>
               <a:t>Open loops make more work. Closed loops make better work.</a:t>
             </a:r>
-            <a:endParaRPr lang="en-US" sz="4400" dirty="0"/>
+            <a:endParaRPr lang="en-US" sz="4000" dirty="0"/>
           </a:p>
         </p:txBody>
       </p:sp>
@@ -21727,7 +21660,7 @@
         </p:nvSpPr>
         <p:spPr>
           <a:xfrm>
-            <a:off x="1088136" y="2754660"/>
+            <a:off x="1088136" y="2496922"/>
             <a:ext cx="4754880" cy="299466"/>
           </a:xfrm>
           <a:prstGeom prst="rect">
@@ -21766,8 +21699,8 @@
         </p:nvSpPr>
         <p:spPr>
           <a:xfrm>
-            <a:off x="1271016" y="3705636"/>
-            <a:ext cx="1005840" cy="1005840"/>
+            <a:off x="1271016" y="3063850"/>
+            <a:ext cx="914400" cy="914400"/>
           </a:xfrm>
           <a:prstGeom prst="ellipse">
             <a:avLst/>
@@ -21788,8 +21721,8 @@
         </p:nvSpPr>
         <p:spPr>
           <a:xfrm>
-            <a:off x="1271016" y="3705636"/>
-            <a:ext cx="1005840" cy="1005840"/>
+            <a:off x="1271016" y="3063850"/>
+            <a:ext cx="914400" cy="914400"/>
           </a:xfrm>
           <a:prstGeom prst="rect">
             <a:avLst/>
@@ -21805,7 +21738,7 @@
               <a:buNone/>
             </a:pPr>
             <a:r>
-              <a:rPr lang="en-US" sz="1100" b="1" dirty="0">
+              <a:rPr lang="en-US" sz="1000" b="1" dirty="0">
                 <a:solidFill>
                   <a:srgbClr val="8A6D14"/>
                 </a:solidFill>
@@ -21815,7 +21748,7 @@
               </a:rPr>
               <a:t>THE RULES</a:t>
             </a:r>
-            <a:endParaRPr lang="en-US" sz="1100" dirty="0"/>
+            <a:endParaRPr lang="en-US" sz="1000" dirty="0"/>
           </a:p>
         </p:txBody>
       </p:sp>
@@ -21827,8 +21760,8 @@
         </p:nvSpPr>
         <p:spPr>
           <a:xfrm>
-            <a:off x="2276856" y="4208556"/>
-            <a:ext cx="3566160" cy="0"/>
+            <a:off x="2185416" y="3521050"/>
+            <a:ext cx="3657600" cy="0"/>
           </a:xfrm>
           <a:prstGeom prst="line">
             <a:avLst/>
@@ -21850,8 +21783,8 @@
         </p:nvSpPr>
         <p:spPr>
           <a:xfrm rot="5400000">
-            <a:off x="2747772" y="4130832"/>
-            <a:ext cx="155448" cy="155448"/>
+            <a:off x="2670048" y="3434182"/>
+            <a:ext cx="128016" cy="173736"/>
           </a:xfrm>
           <a:prstGeom prst="triangle">
             <a:avLst/>
@@ -21870,8 +21803,8 @@
         </p:nvSpPr>
         <p:spPr>
           <a:xfrm rot="5400000">
-            <a:off x="3753612" y="4130832"/>
-            <a:ext cx="155448" cy="155448"/>
+            <a:off x="3675888" y="3434182"/>
+            <a:ext cx="128016" cy="173736"/>
           </a:xfrm>
           <a:prstGeom prst="triangle">
             <a:avLst/>
@@ -21890,8 +21823,8 @@
         </p:nvSpPr>
         <p:spPr>
           <a:xfrm rot="5400000">
-            <a:off x="4759452" y="4130832"/>
-            <a:ext cx="155448" cy="155448"/>
+            <a:off x="4681728" y="3434182"/>
+            <a:ext cx="128016" cy="173736"/>
           </a:xfrm>
           <a:prstGeom prst="triangle">
             <a:avLst/>
@@ -21910,8 +21843,8 @@
         </p:nvSpPr>
         <p:spPr>
           <a:xfrm>
-            <a:off x="2551176" y="3751356"/>
-            <a:ext cx="3291840" cy="219456"/>
+            <a:off x="2459736" y="3063850"/>
+            <a:ext cx="3383280" cy="219456"/>
           </a:xfrm>
           <a:prstGeom prst="rect">
             <a:avLst/>
@@ -21949,8 +21882,8 @@
         </p:nvSpPr>
         <p:spPr>
           <a:xfrm>
-            <a:off x="2551176" y="4446300"/>
-            <a:ext cx="3291840" cy="219456"/>
+            <a:off x="2459736" y="3758794"/>
+            <a:ext cx="3383280" cy="219456"/>
           </a:xfrm>
           <a:prstGeom prst="rect">
             <a:avLst/>
@@ -21988,7 +21921,7 @@
         </p:nvSpPr>
         <p:spPr>
           <a:xfrm>
-            <a:off x="6348679" y="2754660"/>
+            <a:off x="6348679" y="2496922"/>
             <a:ext cx="4754880" cy="299466"/>
           </a:xfrm>
           <a:prstGeom prst="rect">
@@ -22027,8 +21960,8 @@
         </p:nvSpPr>
         <p:spPr>
           <a:xfrm>
-            <a:off x="8241487" y="3723924"/>
-            <a:ext cx="969264" cy="969264"/>
+            <a:off x="8067751" y="2862682"/>
+            <a:ext cx="1316736" cy="1316736"/>
           </a:xfrm>
           <a:prstGeom prst="ellipse">
             <a:avLst/>
@@ -22048,9 +21981,9 @@
           <p:nvPr/>
         </p:nvSpPr>
         <p:spPr>
-          <a:xfrm rot="2700000">
-            <a:off x="9009370" y="3806434"/>
-            <a:ext cx="118872" cy="118872"/>
+          <a:xfrm rot="8100000">
+            <a:off x="9144107" y="2990134"/>
+            <a:ext cx="95098" cy="130759"/>
           </a:xfrm>
           <a:prstGeom prst="triangle">
             <a:avLst/>
@@ -22068,9 +22001,9 @@
           <p:nvPr/>
         </p:nvSpPr>
         <p:spPr>
-          <a:xfrm rot="8100000">
-            <a:off x="9009370" y="4491807"/>
-            <a:ext cx="118872" cy="118872"/>
+          <a:xfrm rot="13500000">
+            <a:off x="9144107" y="3921206"/>
+            <a:ext cx="95098" cy="130759"/>
           </a:xfrm>
           <a:prstGeom prst="triangle">
             <a:avLst/>
@@ -22088,9 +22021,9 @@
           <p:nvPr/>
         </p:nvSpPr>
         <p:spPr>
-          <a:xfrm rot="13500000">
-            <a:off x="8323997" y="4491807"/>
-            <a:ext cx="118872" cy="118872"/>
+          <a:xfrm rot="18900000">
+            <a:off x="8213034" y="3921206"/>
+            <a:ext cx="95098" cy="130759"/>
           </a:xfrm>
           <a:prstGeom prst="triangle">
             <a:avLst/>
@@ -22108,9 +22041,9 @@
           <p:nvPr/>
         </p:nvSpPr>
         <p:spPr>
-          <a:xfrm rot="18900000">
-            <a:off x="8323997" y="3806434"/>
-            <a:ext cx="118872" cy="118872"/>
+          <a:xfrm rot="2700000">
+            <a:off x="8213034" y="2990134"/>
+            <a:ext cx="95098" cy="130759"/>
           </a:xfrm>
           <a:prstGeom prst="triangle">
             <a:avLst/>
@@ -22129,8 +22062,8 @@
         </p:nvSpPr>
         <p:spPr>
           <a:xfrm>
-            <a:off x="8445033" y="3927470"/>
-            <a:ext cx="562173" cy="562173"/>
+            <a:off x="8344266" y="3139196"/>
+            <a:ext cx="763707" cy="763707"/>
           </a:xfrm>
           <a:prstGeom prst="ellipse">
             <a:avLst/>
@@ -22151,8 +22084,8 @@
         </p:nvSpPr>
         <p:spPr>
           <a:xfrm>
-            <a:off x="8490753" y="4076476"/>
-            <a:ext cx="470733" cy="264160"/>
+            <a:off x="8389986" y="3339440"/>
+            <a:ext cx="672267" cy="363220"/>
           </a:xfrm>
           <a:prstGeom prst="rect">
             <a:avLst/>
@@ -22171,7 +22104,7 @@
               <a:buNone/>
             </a:pPr>
             <a:r>
-              <a:rPr lang="en-US" sz="800" b="1" dirty="0">
+              <a:rPr lang="en-US" sz="1100" b="1" dirty="0">
                 <a:solidFill>
                   <a:srgbClr val="8A6D14"/>
                 </a:solidFill>
@@ -22181,7 +22114,7 @@
               </a:rPr>
               <a:t>THE</a:t>
             </a:r>
-            <a:endParaRPr lang="en-US" sz="800" dirty="0"/>
+            <a:endParaRPr lang="en-US" sz="1100" dirty="0"/>
           </a:p>
           <a:p>
             <a:pPr algn="ctr" indent="0" marL="0">
@@ -22191,7 +22124,7 @@
               <a:buNone/>
             </a:pPr>
             <a:r>
-              <a:rPr lang="en-US" sz="800" b="1" dirty="0">
+              <a:rPr lang="en-US" sz="1100" b="1" dirty="0">
                 <a:solidFill>
                   <a:srgbClr val="8A6D14"/>
                 </a:solidFill>
@@ -22201,7 +22134,7 @@
               </a:rPr>
               <a:t>RULES</a:t>
             </a:r>
-            <a:endParaRPr lang="en-US" sz="800" dirty="0"/>
+            <a:endParaRPr lang="en-US" sz="1100" dirty="0"/>
           </a:p>
         </p:txBody>
       </p:sp>
@@ -22213,8 +22146,8 @@
         </p:nvSpPr>
         <p:spPr>
           <a:xfrm>
-            <a:off x="8543239" y="3541044"/>
-            <a:ext cx="365760" cy="365760"/>
+            <a:off x="8561527" y="2698090"/>
+            <a:ext cx="329184" cy="329184"/>
           </a:xfrm>
           <a:prstGeom prst="ellipse">
             <a:avLst/>
@@ -22238,8 +22171,8 @@
         </p:nvSpPr>
         <p:spPr>
           <a:xfrm>
-            <a:off x="8543239" y="3541044"/>
-            <a:ext cx="365760" cy="365760"/>
+            <a:off x="8561527" y="2698090"/>
+            <a:ext cx="329184" cy="329184"/>
           </a:xfrm>
           <a:prstGeom prst="rect">
             <a:avLst/>
@@ -22277,8 +22210,8 @@
         </p:nvSpPr>
         <p:spPr>
           <a:xfrm>
-            <a:off x="9027871" y="4025676"/>
-            <a:ext cx="365760" cy="365760"/>
+            <a:off x="9219895" y="3356458"/>
+            <a:ext cx="329184" cy="329184"/>
           </a:xfrm>
           <a:prstGeom prst="ellipse">
             <a:avLst/>
@@ -22302,8 +22235,8 @@
         </p:nvSpPr>
         <p:spPr>
           <a:xfrm>
-            <a:off x="9027871" y="4025676"/>
-            <a:ext cx="365760" cy="365760"/>
+            <a:off x="9219895" y="3356458"/>
+            <a:ext cx="329184" cy="329184"/>
           </a:xfrm>
           <a:prstGeom prst="rect">
             <a:avLst/>
@@ -22341,8 +22274,8 @@
         </p:nvSpPr>
         <p:spPr>
           <a:xfrm>
-            <a:off x="8543239" y="4510308"/>
-            <a:ext cx="365760" cy="365760"/>
+            <a:off x="8561527" y="4014826"/>
+            <a:ext cx="329184" cy="329184"/>
           </a:xfrm>
           <a:prstGeom prst="ellipse">
             <a:avLst/>
@@ -22366,8 +22299,8 @@
         </p:nvSpPr>
         <p:spPr>
           <a:xfrm>
-            <a:off x="8543239" y="4510308"/>
-            <a:ext cx="365760" cy="365760"/>
+            <a:off x="8561527" y="4014826"/>
+            <a:ext cx="329184" cy="329184"/>
           </a:xfrm>
           <a:prstGeom prst="rect">
             <a:avLst/>
@@ -22405,8 +22338,8 @@
         </p:nvSpPr>
         <p:spPr>
           <a:xfrm>
-            <a:off x="8058607" y="4025676"/>
-            <a:ext cx="365760" cy="365760"/>
+            <a:off x="7903159" y="3356458"/>
+            <a:ext cx="329184" cy="329184"/>
           </a:xfrm>
           <a:prstGeom prst="ellipse">
             <a:avLst/>
@@ -22430,8 +22363,8 @@
         </p:nvSpPr>
         <p:spPr>
           <a:xfrm>
-            <a:off x="8058607" y="4025676"/>
-            <a:ext cx="365760" cy="365760"/>
+            <a:off x="7903159" y="3356458"/>
+            <a:ext cx="329184" cy="329184"/>
           </a:xfrm>
           <a:prstGeom prst="rect">
             <a:avLst/>
@@ -22469,7 +22402,7 @@
         </p:nvSpPr>
         <p:spPr>
           <a:xfrm>
-            <a:off x="813816" y="4663440"/>
+            <a:off x="813816" y="4563466"/>
             <a:ext cx="10570464" cy="715518"/>
           </a:xfrm>
           <a:prstGeom prst="rect">
@@ -22810,9 +22743,9 @@
           <p:nvPr/>
         </p:nvSpPr>
         <p:spPr>
-          <a:xfrm rot="2700000">
-            <a:off x="4296957" y="2616517"/>
-            <a:ext cx="118872" cy="118872"/>
+          <a:xfrm rot="8100000">
+            <a:off x="4308844" y="2610573"/>
+            <a:ext cx="95098" cy="130759"/>
           </a:xfrm>
           <a:prstGeom prst="triangle">
             <a:avLst/>
@@ -22830,9 +22763,9 @@
           <p:nvPr/>
         </p:nvSpPr>
         <p:spPr>
-          <a:xfrm rot="8100000">
-            <a:off x="4296957" y="3831222"/>
-            <a:ext cx="118872" cy="118872"/>
+          <a:xfrm rot="13500000">
+            <a:off x="4308844" y="3825279"/>
+            <a:ext cx="95098" cy="130759"/>
           </a:xfrm>
           <a:prstGeom prst="triangle">
             <a:avLst/>
@@ -22850,9 +22783,9 @@
           <p:nvPr/>
         </p:nvSpPr>
         <p:spPr>
-          <a:xfrm rot="13500000">
-            <a:off x="3082251" y="3831222"/>
-            <a:ext cx="118872" cy="118872"/>
+          <a:xfrm rot="18900000">
+            <a:off x="3094139" y="3825279"/>
+            <a:ext cx="95098" cy="130759"/>
           </a:xfrm>
           <a:prstGeom prst="triangle">
             <a:avLst/>
@@ -22870,9 +22803,9 @@
           <p:nvPr/>
         </p:nvSpPr>
         <p:spPr>
-          <a:xfrm rot="18900000">
-            <a:off x="3082251" y="2616517"/>
-            <a:ext cx="118872" cy="118872"/>
+          <a:xfrm rot="2700000">
+            <a:off x="3094139" y="2610573"/>
+            <a:ext cx="95098" cy="130759"/>
           </a:xfrm>
           <a:prstGeom prst="triangle">
             <a:avLst/>
@@ -24106,9 +24039,9 @@
           <p:nvPr/>
         </p:nvSpPr>
         <p:spPr>
-          <a:xfrm rot="2700000">
-            <a:off x="4251696" y="2597769"/>
-            <a:ext cx="118872" cy="118872"/>
+          <a:xfrm rot="8100000">
+            <a:off x="4263583" y="2591826"/>
+            <a:ext cx="95098" cy="130759"/>
           </a:xfrm>
           <a:prstGeom prst="triangle">
             <a:avLst/>
@@ -24126,9 +24059,9 @@
           <p:nvPr/>
         </p:nvSpPr>
         <p:spPr>
-          <a:xfrm rot="8100000">
-            <a:off x="4251696" y="3721954"/>
-            <a:ext cx="118872" cy="118872"/>
+          <a:xfrm rot="13500000">
+            <a:off x="4263583" y="3716010"/>
+            <a:ext cx="95098" cy="130759"/>
           </a:xfrm>
           <a:prstGeom prst="triangle">
             <a:avLst/>
@@ -24146,9 +24079,9 @@
           <p:nvPr/>
         </p:nvSpPr>
         <p:spPr>
-          <a:xfrm rot="13500000">
-            <a:off x="3127512" y="3721954"/>
-            <a:ext cx="118872" cy="118872"/>
+          <a:xfrm rot="18900000">
+            <a:off x="3139399" y="3716010"/>
+            <a:ext cx="95098" cy="130759"/>
           </a:xfrm>
           <a:prstGeom prst="triangle">
             <a:avLst/>
@@ -24166,9 +24099,9 @@
           <p:nvPr/>
         </p:nvSpPr>
         <p:spPr>
-          <a:xfrm rot="18900000">
-            <a:off x="3127512" y="2597769"/>
-            <a:ext cx="118872" cy="118872"/>
+          <a:xfrm rot="2700000">
+            <a:off x="3139399" y="2591826"/>
+            <a:ext cx="95098" cy="130759"/>
           </a:xfrm>
           <a:prstGeom prst="triangle">
             <a:avLst/>
@@ -25441,9 +25374,9 @@
           <p:nvPr/>
         </p:nvSpPr>
         <p:spPr>
-          <a:xfrm rot="2700000">
-            <a:off x="4296957" y="2616517"/>
-            <a:ext cx="118872" cy="118872"/>
+          <a:xfrm rot="8100000">
+            <a:off x="4308844" y="2610573"/>
+            <a:ext cx="95098" cy="130759"/>
           </a:xfrm>
           <a:prstGeom prst="triangle">
             <a:avLst/>
@@ -25461,9 +25394,9 @@
           <p:nvPr/>
         </p:nvSpPr>
         <p:spPr>
-          <a:xfrm rot="8100000">
-            <a:off x="4296957" y="3831222"/>
-            <a:ext cx="118872" cy="118872"/>
+          <a:xfrm rot="13500000">
+            <a:off x="4308844" y="3825279"/>
+            <a:ext cx="95098" cy="130759"/>
           </a:xfrm>
           <a:prstGeom prst="triangle">
             <a:avLst/>
@@ -25481,9 +25414,9 @@
           <p:nvPr/>
         </p:nvSpPr>
         <p:spPr>
-          <a:xfrm rot="13500000">
-            <a:off x="3082251" y="3831222"/>
-            <a:ext cx="118872" cy="118872"/>
+          <a:xfrm rot="18900000">
+            <a:off x="3094139" y="3825279"/>
+            <a:ext cx="95098" cy="130759"/>
           </a:xfrm>
           <a:prstGeom prst="triangle">
             <a:avLst/>
@@ -25501,9 +25434,9 @@
           <p:nvPr/>
         </p:nvSpPr>
         <p:spPr>
-          <a:xfrm rot="18900000">
-            <a:off x="3082251" y="2616517"/>
-            <a:ext cx="118872" cy="118872"/>
+          <a:xfrm rot="2700000">
+            <a:off x="3094139" y="2610573"/>
+            <a:ext cx="95098" cy="130759"/>
           </a:xfrm>
           <a:prstGeom prst="triangle">
             <a:avLst/>
@@ -27113,7 +27046,7 @@
                 <a:ea typeface="Arial" pitchFamily="34" charset="-122"/>
                 <a:cs typeface="Arial" pitchFamily="34" charset="-120"/>
               </a:rPr>
-              <a:t>We move together. Every step ends at a checkpoint: type ✅ in the chat.</a:t>
+              <a:t>We move together. Every step ends at a checkpoint: type ✓ in the chat.</a:t>
             </a:r>
             <a:endParaRPr lang="en-US" sz="1500" dirty="0"/>
           </a:p>

</xml_diff>

<commit_message>
Password is now donna2026 (site gate, deck slide 2 and its notes, README, verification notes)
Stylesheet and script links bumped to ?v=3.1.2 so every browser fetches the new gate script.

Co-Authored-By: Claude Fable 5.1 <noreply@anthropic.com>
Claude-Session: https://claude.ai/code/session_0193JnwZiFkcYnyNggnZj1Hm
</commit_message>
<xml_diff>
--- a/decks/build-your-own-donna-v3.pptx
+++ b/decks/build-your-own-donna-v3.pptx
@@ -1545,7 +1545,7 @@
             <a:r>
               <a:rPr lang="en-US" dirty="0"/>
               <a:t>[TIMING] 1 min.
-[SAY] Open the site now, on your phone or in a tab beside Claude. Type the password: suits, all lowercase. The TAs are putting the link and the password in the chat.
+[SAY] Open the site now, on your phone or in a tab beside Claude. Type the password: donna2026, all lowercase, no spaces. The TAs are putting the link and the password in the chat.
 [DO] Say the password out loud twice and paste the link and the password into the Zoom chat yourself. Wait for checkmarks.
 [WATCH] Someone will type the password with a capital letter or a space; the site ignores both. Someone else will be on the promo page instead of the instructions; the link in the chat fixes it.
 [NEXT] Fifty-five seconds of silence. Let the video do the talking.</a:t>
@@ -13800,7 +13800,7 @@
                 <a:ea typeface="Georgia" pitchFamily="34" charset="-122"/>
                 <a:cs typeface="Georgia" pitchFamily="34" charset="-120"/>
               </a:rPr>
-              <a:t>suits</a:t>
+              <a:t>donna2026</a:t>
             </a:r>
             <a:endParaRPr lang="en-US" sz="4800" dirty="0"/>
           </a:p>

</xml_diff>

<commit_message>
The build-along site is https://donnainstructions.denisegosnell.ai/
New URL on deck slide 2, every step divider and the two closing slides; the front page QR code
and URL text regenerated for it; README (with the custom-domain setup notes), the v3 spec and
the old deck notes updated; CNAME file added for GitHub Pages.

Co-Authored-By: Claude Fable 5.1 <noreply@anthropic.com>
Claude-Session: https://claude.ai/code/session_0193JnwZiFkcYnyNggnZj1Hm
</commit_message>
<xml_diff>
--- a/decks/build-your-own-donna-v3.pptx
+++ b/decks/build-your-own-donna-v3.pptx
@@ -9878,7 +9878,7 @@
                 <a:ea typeface="Arial" pitchFamily="34" charset="-122"/>
                 <a:cs typeface="Arial" pitchFamily="34" charset="-120"/>
               </a:rPr>
-              <a:t>denisekgosnell.github.io/Donna</a:t>
+              <a:t>donnainstructions.denisegosnell.ai</a:t>
             </a:r>
             <a:endParaRPr lang="en-US" sz="1600" dirty="0"/>
           </a:p>
@@ -12254,7 +12254,7 @@
                 <a:ea typeface="Arial" pitchFamily="34" charset="-122"/>
                 <a:cs typeface="Arial" pitchFamily="34" charset="-120"/>
               </a:rPr>
-              <a:t>denisekgosnell.github.io/Donna</a:t>
+              <a:t>donnainstructions.denisegosnell.ai</a:t>
             </a:r>
             <a:endParaRPr lang="en-US" sz="1600" dirty="0"/>
           </a:p>
@@ -13694,7 +13694,7 @@
               <a:buNone/>
             </a:pPr>
             <a:r>
-              <a:rPr lang="en-US" sz="4000" b="1" dirty="0">
+              <a:rPr lang="en-US" sz="3600" b="1" dirty="0">
                 <a:solidFill>
                   <a:srgbClr val="14213D"/>
                 </a:solidFill>
@@ -13702,9 +13702,9 @@
                 <a:ea typeface="Georgia" pitchFamily="34" charset="-122"/>
                 <a:cs typeface="Georgia" pitchFamily="34" charset="-120"/>
               </a:rPr>
-              <a:t>denisekgosnell.github.io/Donna</a:t>
-            </a:r>
-            <a:endParaRPr lang="en-US" sz="4000" dirty="0"/>
+              <a:t>donnainstructions.denisegosnell.ai</a:t>
+            </a:r>
+            <a:endParaRPr lang="en-US" sz="3600" dirty="0"/>
           </a:p>
         </p:txBody>
       </p:sp>
@@ -15261,7 +15261,7 @@
                 <a:ea typeface="Arial" pitchFamily="34" charset="-122"/>
                 <a:cs typeface="Arial" pitchFamily="34" charset="-120"/>
               </a:rPr>
-              <a:t>denisekgosnell.github.io/Donna</a:t>
+              <a:t>donnainstructions.denisegosnell.ai</a:t>
             </a:r>
             <a:endParaRPr lang="en-US" sz="1600" dirty="0"/>
           </a:p>
@@ -18761,7 +18761,7 @@
                 <a:ea typeface="Arial" pitchFamily="34" charset="-122"/>
                 <a:cs typeface="Arial" pitchFamily="34" charset="-120"/>
               </a:rPr>
-              <a:t>denisekgosnell.github.io/Donna</a:t>
+              <a:t>donnainstructions.denisegosnell.ai</a:t>
             </a:r>
             <a:endParaRPr lang="en-US" sz="1600" dirty="0"/>
           </a:p>
@@ -23089,7 +23089,7 @@
                 <a:ea typeface="Arial" pitchFamily="34" charset="-122"/>
                 <a:cs typeface="Arial" pitchFamily="34" charset="-120"/>
               </a:rPr>
-              <a:t>denisekgosnell.github.io/Donna   ·   denise@denisegosnell.ai</a:t>
+              <a:t>donnainstructions.denisegosnell.ai   ·   denise@denisegosnell.ai</a:t>
             </a:r>
             <a:endParaRPr lang="en-US" sz="1600" dirty="0"/>
           </a:p>
@@ -23472,7 +23472,7 @@
                 <a:ea typeface="Arial" pitchFamily="34" charset="-122"/>
                 <a:cs typeface="Arial" pitchFamily="34" charset="-120"/>
               </a:rPr>
-              <a:t>denisekgosnell.github.io/Donna   ·   denise@denisegosnell.ai</a:t>
+              <a:t>donnainstructions.denisegosnell.ai   ·   denise@denisegosnell.ai</a:t>
             </a:r>
             <a:endParaRPr lang="en-US" sz="1600" dirty="0"/>
           </a:p>

</xml_diff>

<commit_message>
Pacing to a 1:30 finish, a step clock on every step page, and a simplification pass for beginners
Deck opens 12:08 after an eight-minute preamble; Step 1 12:25, Step 2 12:38, Step 3 12:55,
Step 4 1:08, Donna live 1:20, done 1:30 (82 minutes of deck timing, checked by verify.py).
Each step page opens with its minutes and start time in four zones, top and centre. The four
step pages are rewritten for adult beginners: one action per step, exact buttons, the prompt,
one "it worked when" line, and a single collapsed "If something goes wrong" list per page.

Co-Authored-By: Claude Fable 5.1 <noreply@anthropic.com>
Claude-Session: https://claude.ai/code/session_0193JnwZiFkcYnyNggnZj1Hm
</commit_message>
<xml_diff>
--- a/decks/build-your-own-donna-v3.pptx
+++ b/decks/build-your-own-donna-v3.pptx
@@ -536,8 +536,8 @@
             <a:r>
               <a:rPr lang="en-US" dirty="0"/>
               <a:t>[TIMING] 1 min.
-[SAY] She ran the best closer in New York City. Today she comes to work for you. By 1:23 Eastern every one of you owns a working Donna. Not a demo. Yours, on your own inbox, and she gets better every Friday.
-[DO] The preamble before this slide ran 12:00 to 12:10. Zoom housekeeping in one breath: Claude open on your laptop, the chat is for two things, a checkmark when you have it and a word when you are stuck. Name the TAs working the chat and the breakout rooms.
+[SAY] She ran the best closer in New York City. Today she comes to work for you. By 1:20 Eastern every one of you owns a working Donna. Not a demo. Yours, on your own inbox, and she gets better every Friday.
+[DO] The preamble before this slide ran 12:00 to 12:08. Zoom housekeeping in one breath: Claude open on your laptop, the chat is for two things, a checkmark when you have it and a word when you are stuck. Name the TAs working the chat and the breakout rooms.
 [WATCH] Do not start until the chat shows checkmarks from most of the room. The people who fall behind fall behind here, not later.
 [NEXT] Here is how the ninety minutes go.</a:t>
             </a:r>
@@ -999,7 +999,7 @@
 [SAY] Read all five slowly. This slide buys calm for the next hour.
 [DO] Rules 1 and 2 kill the unspoken fear. Rule 3 is how we move on Zoom: a checkmark in the chat at every checkpoint, and nobody moves until the count matches. Rule 5: say so in the chat or raise your hand, and a TA takes you into a Zoom room one to one.
 [WATCH] After rule 5, say the last line out loud. It is the one that keeps people from hiding.
-[NEXT] Four steps. By 1:23 she is working for you.</a:t>
+[NEXT] Four steps. By 1:20 she is working for you.</a:t>
             </a:r>
             <a:endParaRPr lang="en-US" dirty="0"/>
           </a:p>
@@ -1088,7 +1088,7 @@
             <a:r>
               <a:rPr lang="en-US" dirty="0"/>
               <a:t>[TIMING] 1 min.
-[SAY] Four steps, one per station of the loop you just saw. Connect at 12:27, teach at 12:41, run at 12:55, retrain at 1:11. At 1:23 she is working for you, and she has already given herself her first performance review.
+[SAY] Four steps, one per station of the loop you just saw. Connect at 12:25, teach at 12:38, run at 12:55, retrain at 1:08. At 1:20 she is working for you, and she has already given herself her first performance review.
 [DO] Say the arc out loud, then point at the clock on each card. From here, each step opens with one slide that says what we are doing, then we switch to the site.
 [WATCH] Nobody types anything longer than one sentence today. Say that; it lowers the temperature.
 [NEXT] Last thing before we build: everyone opens the instructions.</a:t>
@@ -1274,7 +1274,7 @@
               <a:t>[TIMING] 1 min.
 [SAY] Step one, three things: create her project, connect the three Google accounts, then two prompts. The desk before the mail.
 [DO] Read the three lines. Then switch the screen share to the site, Step 1, and stay there until the checkpoint.
-[WATCH] Watch the pip in the top right. One of four stations lit. By 1:23 all four are.
+[WATCH] Watch the pip in the top right. One of four stations lit. By 1:20 all four are.
 [NEXT] The site, Step 1.</a:t>
             </a:r>
             <a:endParaRPr lang="en-US" dirty="0"/>
@@ -1455,7 +1455,7 @@
           <a:p>
             <a:r>
               <a:rPr lang="en-US" dirty="0"/>
-              <a:t>[TIMING] 5 min.
+              <a:t>[TIMING] 4 min.
 [SAY] Nothing until the chat shows a checkmark from nearly everyone.
 [DO] Run it live on your own screen first, then hold. Count the checkmarks out loud. The TAs chase the stuck.
 [WATCH] If a connector is stuck: disconnect, reconnect, confirm the account. If someone is hopelessly stuck, a TA takes them into a Zoom room and the room keeps moving.
@@ -1548,7 +1548,7 @@
             <a:r>
               <a:rPr lang="en-US" dirty="0"/>
               <a:t>[TIMING] 1 min.
-[SAY] Three acts. First the idea: open loops and closed loops, and why an agent is just a document. Then we build, four steps, and by 1:23 she is working your inbox. Then the wrap: what you built, where it turns next, and your first Friday.
+[SAY] Three acts. First the idea: open loops and closed loops, and why an agent is just a document. Then we build, four steps, and by 1:20 she is working your inbox. Then the wrap: what you built, where it turns next, and your first Friday.
 [DO] Point at the middle card. That is most of the ninety minutes, and most of it is you pasting.
 [WATCH] Do not read the card text. Say the three act names and the clock on the middle one.
 [NEXT] Fifty-five seconds of silence. Let the video do the talking.</a:t>
@@ -1731,7 +1731,7 @@
           <a:p>
             <a:r>
               <a:rPr lang="en-US" dirty="0"/>
-              <a:t>[TIMING] 9 min.
+              <a:t>[TIMING] 11 min.
 [SAY] You do not write the document. You answer four questions and she writes it. Reply Now, By End of Day, your priorities, your voice. Take your time; specific answers make a better Donna.
 [DO] Everyone pastes the template from the site into a NEW chat inside the Donna project. Gate: every screen shows 'Four questions. Take your time.' and QUESTION 1 OF 4. Checkmarks in the chat. Then let them answer. Circulate through the chat with the TAs.
 [WATCH] Someone will paste OUTSIDE the Donna project and get generic results; get them inside the project, it is the first note on the page. Nobody gets hurried: there is no shortcut phrase this time.
@@ -1823,7 +1823,7 @@
           <a:p>
             <a:r>
               <a:rPr lang="en-US" dirty="0"/>
-              <a:t>[TIMING] 4 min.
+              <a:t>[TIMING] 5 min.
 [SAY] You will never re-explain your rules again. That is the difference between a chat and a playbook.
 [DO] After the OPEN FOR BUSINESS banner, everyone runs the one-sentence ritual inside the project. Hold until the checkmarks say every screen shows a table.
 [WATCH] Reply-Now drafts are already sitting in their Drafts folder. Have them check; that is the gasp.
@@ -2007,7 +2007,7 @@
           <a:p>
             <a:r>
               <a:rPr lang="en-US" dirty="0"/>
-              <a:t>[TIMING] 6 min.
+              <a:t>[TIMING] 5 min.
 [SAY] A skill written in chat does not exist until you upload it. The file is a zip; the Skills screen wants a zip. Go slow and demo it on screen.
 [DO] Three beats. She writes it. You DOWNLOAD it. You UPLOAD it under Customize, Skills, plus, Create skill, Upload a skill. Wait until the chat says every screen shows donna-triage in the list.
 [WATCH] Stay in the SAME chat as step two; a fresh chat has not met them yet and writes a blank template. The gotchas are on the site: no Skills menu means the capability switch is off; a refused upload means the zip is not a folder with SKILL.md inside. The workaround for anyone: paste the playbook text into the scheduled task itself.
@@ -2099,10 +2099,10 @@
           <a:p>
             <a:r>
               <a:rPr lang="en-US" dirty="0"/>
-              <a:t>[TIMING] 5 min.
+              <a:t>[TIMING] 4 min.
 [SAY] The last line of that prompt is the finale of this step: a dry run, right now, with today's event ten minutes out so the email lands while we are still together.
 [DO] Grab the prompt from the site rather than retyping. Scheduled in the left sidebar, New task, Create with Claude. If Claude asks how much she may do without checking in, pick the hands-free option. Free-plan people: no Scheduled menu; they run her by hand with Triage my inbox, and the site says so.
-[WATCH] Scheduled tasks run on Anthropic's side now, so a closed laptop is fine; say that plainly. 'My local time' matters: half this room is in Europe. Paste by 1:06 at the latest so the event lands before step four.
+[WATCH] Scheduled tasks run on Anthropic's side now, so a closed laptop is fine; say that plainly. 'My local time' matters: half this room is in Europe. Paste by 1:04 at the latest so the event lands before step four.
 [NEXT] Everybody watch your calendar.</a:t>
             </a:r>
             <a:endParaRPr lang="en-US" dirty="0"/>
@@ -2191,10 +2191,10 @@
           <a:p>
             <a:r>
               <a:rPr lang="en-US" dirty="0"/>
-              <a:t>[TIMING] 4 min.
+              <a:t>[TIMING] 3 min.
 [SAY] Open today's calendar. The checkmark is the event with the triage inside it. The email arrives a minute before it starts, right as step four begins.
 [DO] Everyone opens the event: the whole triage in its description, drafts waiting. Hold the silence. Checkmarks in the chat.
-[WATCH] The event appears when the dry run finishes, two to five minutes after the paste; the email follows ten minutes after the task started, so most land around 1:15. Do not wait for the email here. Move on at 1:11 and let it arrive during step four.
+[WATCH] The event appears when the dry run finishes, two to five minutes after the paste; the email follows ten minutes after the task started, so most land around 1:12. Do not wait for the email here. Move on at 1:08 and let it arrive during step four.
 [NEXT] Three stations lit. Now the one almost nobody builds.</a:t>
             </a:r>
             <a:endParaRPr lang="en-US" dirty="0"/>
@@ -2375,9 +2375,9 @@
           <a:p>
             <a:r>
               <a:rPr lang="en-US" dirty="0"/>
-              <a:t>[TIMING] 6 min.
+              <a:t>[TIMING] 5 min.
 [SAY] Your Sent folder is her report card. She reads the reports she wrote, the drafts she saved, and the emails you actually sent, and she proposes changes to her own playbook. Numbered, each with a because. Nothing changes until you say approve.
-[DO] Paste first, by 1:13, then talk. Same place as the daily shift: Scheduled, New task, paste. The last line runs it right now on this week so far, with today's event ten minutes out, which lands at 1:23 if the paste is at 1:13. Talk through the Sent-folder idea while she reads the week. Yes, on a Wednesday: the Sent folder since Monday gives her plenty to say.
+[DO] Paste first, by 1:10, then talk. Same place as the daily shift: Scheduled, New task, paste. The last line runs it right now on this week so far, with today's event ten minutes out, which lands at 1:20 if the paste is at 1:10. Talk through the Sent-folder idea while she reads the week. Yes, on a Wednesday: the Sent folder since Monday gives her plenty to say.
 [WATCH] Someone will ask whether she can just apply the changes herself. No, and that is the point: the human signature is what closes the loop. Monday, one paste and one upload, only when she proposes something.
 [NEXT] While she reads: the reframe.</a:t>
             </a:r>
@@ -2471,7 +2471,7 @@
 [SAY] While her review is landing: recap the loop with THEIR artifacts. The playbook she wrote, the skill file they own, the schedule it runs on, the Friday it learns on. They did not learn a tool today. They built a loop, and closed it.
 [DO] Two minutes, no more. Then the calendar.
 [WATCH] Nothing.
-[NEXT] 1:23. Open your calendar.</a:t>
+[NEXT] 1:20. Open your calendar.</a:t>
             </a:r>
             <a:endParaRPr lang="en-US" dirty="0"/>
           </a:p>
@@ -2651,7 +2651,7 @@
           <a:p>
             <a:r>
               <a:rPr lang="en-US" dirty="0"/>
-              <a:t>[TIMING] 3 min.
+              <a:t>[TIMING] 4 min.
 [SAY] Nothing. Let it land. Then: four stations. Connect, teach, run, retrain. That is a learning system, and it is yours.
 [DO] Everyone opens the event: proposed changes at the top, numbered, each with a because. Checkmarks in the chat. Point at the pip: all four lit, and the caption says the loop is closed.
 [WATCH] A few reviews will land a minute or two late. Keep talking; they will arrive during the next slide.
@@ -2745,7 +2745,7 @@
               <a:rPr lang="en-US" dirty="0"/>
               <a:t>[TIMING] 1 min.
 [SAY] Same three cards from the top of the hour. The idea: every workflow is a loop, and closed loops get better. The build: a project, a playbook she wrote, a skill you own, two standing orders, and she is live. The wrap starts now.
-[DO] Point at each card in turn. This is the slide you promised them at 12:12.
+[DO] Point at each card in turn. This is the slide you promised them at 12:10.
 [WATCH] Free-plan people built the same thing; their standing orders are two phone reminders. Say so if you see the question in the chat.
 [NEXT] Where does the loop turn next?</a:t>
             </a:r>
@@ -2835,9 +2835,9 @@
           <a:p>
             <a:r>
               <a:rPr lang="en-US" dirty="0"/>
-              <a:t>[TIMING] 12 min.
+              <a:t>[TIMING] 5 min.
 [SAY] Same four stations, pointed at the rest of your work. Every one of these questions is a workflow somebody on this call is doing by hand.
-[DO] Facilitate from the chat; read answers aloud and map each one onto the ring so people hear their own use case become buildable. Three or four answers per station.
+[DO] Five minutes only. Facilitate from the chat; read two or three answers aloud and map each onto the ring so people hear their own use case become buildable.
 [WATCH] Give one personal story: the two-calendar morning shift is your own daily driver, so say so. The RETRAIN answers are your pipeline for the next workshop. Write them down.
 [NEXT] What happens next, starting tomorrow.</a:t>
             </a:r>
@@ -9488,7 +9488,7 @@
                 <a:ea typeface="Georgia" pitchFamily="34" charset="-122"/>
                 <a:cs typeface="Georgia" pitchFamily="34" charset="-120"/>
               </a:rPr>
-              <a:t>Four steps. By 1:23 she’s working for you.</a:t>
+              <a:t>Four steps. By 1:20 she’s working for you.</a:t>
             </a:r>
             <a:endParaRPr lang="en-US" sz="3400" dirty="0"/>
           </a:p>
@@ -9667,7 +9667,7 @@
                 <a:ea typeface="Georgia" pitchFamily="34" charset="-122"/>
                 <a:cs typeface="Georgia" pitchFamily="34" charset="-120"/>
               </a:rPr>
-              <a:t>12:27</a:t>
+              <a:t>12:25</a:t>
             </a:r>
             <a:endParaRPr lang="en-US" sz="2200" dirty="0"/>
           </a:p>
@@ -9846,7 +9846,7 @@
                 <a:ea typeface="Georgia" pitchFamily="34" charset="-122"/>
                 <a:cs typeface="Georgia" pitchFamily="34" charset="-120"/>
               </a:rPr>
-              <a:t>12:41</a:t>
+              <a:t>12:38</a:t>
             </a:r>
             <a:endParaRPr lang="en-US" sz="2200" dirty="0"/>
           </a:p>
@@ -10204,7 +10204,7 @@
                 <a:ea typeface="Georgia" pitchFamily="34" charset="-122"/>
                 <a:cs typeface="Georgia" pitchFamily="34" charset="-120"/>
               </a:rPr>
-              <a:t>1:11</a:t>
+              <a:t>1:08</a:t>
             </a:r>
             <a:endParaRPr lang="en-US" sz="2200" dirty="0"/>
           </a:p>
@@ -13449,7 +13449,7 @@
                 <a:ea typeface="Georgia" pitchFamily="34" charset="-122"/>
                 <a:cs typeface="Georgia" pitchFamily="34" charset="-120"/>
               </a:rPr>
-              <a:t>Three acts, ninety minutes.</a:t>
+              <a:t>Three acts, done by 1:30.</a:t>
             </a:r>
             <a:endParaRPr lang="en-US" sz="4000" dirty="0"/>
           </a:p>
@@ -13609,7 +13609,7 @@
                 <a:ea typeface="Arial" pitchFamily="34" charset="-122"/>
                 <a:cs typeface="Arial" pitchFamily="34" charset="-120"/>
               </a:rPr>
-              <a:t>12:10 TO 12:27</a:t>
+              <a:t>12:08 TO 12:25</a:t>
             </a:r>
             <a:endParaRPr lang="en-US" sz="1600" dirty="0"/>
           </a:p>
@@ -13811,7 +13811,7 @@
                 <a:ea typeface="Arial" pitchFamily="34" charset="-122"/>
                 <a:cs typeface="Arial" pitchFamily="34" charset="-120"/>
               </a:rPr>
-              <a:t>12:27 TO 1:23</a:t>
+              <a:t>12:25 TO 1:20</a:t>
             </a:r>
             <a:endParaRPr lang="en-US" sz="1600" dirty="0"/>
           </a:p>
@@ -13853,7 +13853,7 @@
                 <a:ea typeface="Arial" pitchFamily="34" charset="-122"/>
                 <a:cs typeface="Arial" pitchFamily="34" charset="-120"/>
               </a:rPr>
-              <a:t>Four steps: connect, teach, run, retrain. By 1:23, Donna is working your inbox.</a:t>
+              <a:t>Four steps: connect, teach, run, retrain. By 1:20, Donna is working your inbox.</a:t>
             </a:r>
             <a:endParaRPr lang="en-US" sz="1600" dirty="0"/>
           </a:p>
@@ -14013,7 +14013,7 @@
                 <a:ea typeface="Arial" pitchFamily="34" charset="-122"/>
                 <a:cs typeface="Arial" pitchFamily="34" charset="-120"/>
               </a:rPr>
-              <a:t>1:23 TO 1:40</a:t>
+              <a:t>1:20 TO 1:30</a:t>
             </a:r>
             <a:endParaRPr lang="en-US" sz="1600" dirty="0"/>
           </a:p>
@@ -19102,7 +19102,7 @@
                 <a:ea typeface="Arial" pitchFamily="34" charset="-122"/>
                 <a:cs typeface="Arial" pitchFamily="34" charset="-120"/>
               </a:rPr>
-              <a:t>Full prompt on the site, Step 3. Paste by 1:06.</a:t>
+              <a:t>Full prompt on the site, Step 3. Paste by 1:04.</a:t>
             </a:r>
             <a:endParaRPr lang="en-US" sz="1600" dirty="0"/>
           </a:p>
@@ -19935,7 +19935,7 @@
                 <a:ea typeface="Georgia" pitchFamily="34" charset="-122"/>
                 <a:cs typeface="Georgia" pitchFamily="34" charset="-120"/>
               </a:rPr>
-              <a:t>1:11</a:t>
+              <a:t>1:08</a:t>
             </a:r>
             <a:endParaRPr lang="en-US" sz="7200" dirty="0"/>
           </a:p>
@@ -20675,7 +20675,7 @@
                 <a:ea typeface="Arial" pitchFamily="34" charset="-122"/>
                 <a:cs typeface="Arial" pitchFamily="34" charset="-120"/>
               </a:rPr>
-              <a:t>Watch her first review land at 1:23.</a:t>
+              <a:t>Watch her first review land at 1:20.</a:t>
             </a:r>
             <a:endParaRPr lang="en-US" sz="1800" dirty="0"/>
           </a:p>
@@ -21593,7 +21593,7 @@
                 <a:ea typeface="Arial" pitchFamily="34" charset="-122"/>
                 <a:cs typeface="Arial" pitchFamily="34" charset="-120"/>
               </a:rPr>
-              <a:t>Full prompt on the site, Step 4. Paste by 1:13.</a:t>
+              <a:t>Full prompt on the site, Step 4. Paste by 1:10.</a:t>
             </a:r>
             <a:endParaRPr lang="en-US" sz="1600" dirty="0"/>
           </a:p>
@@ -22906,7 +22906,7 @@
                 <a:ea typeface="Georgia" pitchFamily="34" charset="-122"/>
                 <a:cs typeface="Georgia" pitchFamily="34" charset="-120"/>
               </a:rPr>
-              <a:t>1:23</a:t>
+              <a:t>1:20</a:t>
             </a:r>
             <a:endParaRPr lang="en-US" sz="7200" dirty="0"/>
           </a:p>
@@ -23669,7 +23669,7 @@
                 <a:ea typeface="Arial" pitchFamily="34" charset="-122"/>
                 <a:cs typeface="Arial" pitchFamily="34" charset="-120"/>
               </a:rPr>
-              <a:t>DONE, 1:23</a:t>
+              <a:t>DONE, 1:20</a:t>
             </a:r>
             <a:endParaRPr lang="en-US" sz="1600" dirty="0"/>
           </a:p>

</xml_diff>

<commit_message>
Step 3: she creates the skill in the chat and you click Save; no download, no upload
Site, deck, playbook and README now describe the one-click path: the skill card appears in
the chat, Save adds it to Customize → Skills. The zip download and upload remain only as the
long way under "If something goes wrong". Monday's signature updates the skill in chat too.

Co-Authored-By: Claude Fable 5.1 <noreply@anthropic.com>
Claude-Session: https://claude.ai/code/session_0193JnwZiFkcYnyNggnZj1Hm
</commit_message>
<xml_diff>
--- a/decks/build-your-own-donna-v3.pptx
+++ b/decks/build-your-own-donna-v3.pptx
@@ -1916,7 +1916,7 @@
             <a:r>
               <a:rPr lang="en-US" dirty="0"/>
               <a:t>[TIMING] 1 min.
-[SAY] Step three is where it stops being a conversation and becomes an employee. Three things: she writes her playbook file, you upload it as a skill, then you schedule the 4:30 shift.
+[SAY] Step three is where it stops being a conversation and becomes an employee. Three things: she writes her playbook as a skill, you click Save, then you schedule the 4:30 shift.
 [DO] Pip moves to RUN. Read the three lines, then share the site, Step 3.
 [WATCH] Free-plan people: the first two work for them; the schedule needs a paid plan, and the site says what they do instead.
 [NEXT] The site, Step 3.</a:t>
@@ -2008,9 +2008,9 @@
             <a:r>
               <a:rPr lang="en-US" dirty="0"/>
               <a:t>[TIMING] 5 min.
-[SAY] A skill written in chat does not exist until you upload it. The file is a zip; the Skills screen wants a zip. Go slow and demo it on screen.
-[DO] Three beats. She writes it. You DOWNLOAD it. You UPLOAD it under Customize, Skills, plus, Create skill, Upload a skill. Wait until the chat says every screen shows donna-triage in the list.
-[WATCH] Stay in the SAME chat as step two; a fresh chat has not met them yet and writes a blank template. The gotchas are on the site: no Skills menu means the capability switch is off; a refused upload means the zip is not a folder with SKILL.md inside. The workaround for anyone: paste the playbook text into the scheduled task itself.
+[SAY] A skill written in chat does not exist until you save it. She writes it as a skill card; you click Save; it is in your skills list. Go slow and demo it on screen.
+[DO] Three beats. She writes it. You click SAVE on the card. You check Customize, Skills, and donna-triage is there and on. Wait until the chat says every screen shows it.
+[WATCH] Stay in the SAME chat as step two; a fresh chat has not met them yet and writes a blank template. If someone gets a file instead of a skill card, the long way is on the site: ask for the zip, download, Customize, Skills, Create skill, Upload a skill. No Skills menu means the capability switch is off. The workaround for anyone: paste the playbook text into the scheduled task itself.
 [NEXT] Now give her the 4:30 shift.</a:t>
             </a:r>
             <a:endParaRPr lang="en-US" dirty="0"/>
@@ -2378,7 +2378,7 @@
               <a:t>[TIMING] 5 min.
 [SAY] Your Sent folder is her report card. She reads the reports she wrote, the drafts she saved, and the emails you actually sent, and she proposes changes to her own playbook. Numbered, each with a because. Nothing changes until you say approve.
 [DO] Paste first, by 1:10, then talk. Same place as the daily shift: Scheduled, New task, paste. The last line runs it right now on this week so far, with today's event ten minutes out, which lands at 1:20 if the paste is at 1:10. Talk through the Sent-folder idea while she reads the week. Yes, on a Wednesday: the Sent folder since Monday gives her plenty to say.
-[WATCH] Someone will ask whether she can just apply the changes herself. No, and that is the point: the human signature is what closes the loop. Monday, one paste and one upload, only when she proposes something.
+[WATCH] Someone will ask whether she can just apply the changes herself. No, and that is the point: the human signature is what closes the loop. Monday, one paste and one Save, only when she proposes something.
 [NEXT] While she reads: the reframe.</a:t>
             </a:r>
             <a:endParaRPr lang="en-US" dirty="0"/>
@@ -2928,7 +2928,7 @@
             <a:r>
               <a:rPr lang="en-US" dirty="0"/>
               <a:t>[TIMING] 3 min.
-[SAY] Tomorrow at 4:30 she works her first real shift, and the email lands at 4:39. Friday at 3:00 she reads her week. Monday at 8:00 her Week in Review is on your calendar, and you sign it with one paste and one upload. If she gets it wrong, you do not need a better prompt. You need to retrain with better info, and more specific info.
+[SAY] Tomorrow at 4:30 she works her first real shift, and the email lands at 4:39. Friday at 3:00 she reads her week. Monday at 8:00 her Week in Review is on your calendar, and you sign it with one paste and one Save. If she gets it wrong, you do not need a better prompt. You need to retrain with better info, and more specific info.
 [DO] Point at Monday. That is the loop closing for the first time without you in the room.
 [WATCH] The site stays up: every prompt, every rescue prompt, the Monday signature. Questions to the email address, any time.
 [NEXT] Send-off.</a:t>
@@ -17122,7 +17122,7 @@
                 <a:ea typeface="Arial" pitchFamily="34" charset="-122"/>
                 <a:cs typeface="Arial" pitchFamily="34" charset="-120"/>
               </a:rPr>
-              <a:t>She writes her playbook file.</a:t>
+              <a:t>She writes her playbook as a skill.</a:t>
             </a:r>
             <a:endParaRPr lang="en-US" sz="1800" dirty="0"/>
           </a:p>
@@ -17175,7 +17175,7 @@
                 <a:ea typeface="Arial" pitchFamily="34" charset="-122"/>
                 <a:cs typeface="Arial" pitchFamily="34" charset="-120"/>
               </a:rPr>
-              <a:t>You upload it as a skill.</a:t>
+              <a:t>You click Save.</a:t>
             </a:r>
             <a:endParaRPr lang="en-US" sz="1800" dirty="0"/>
           </a:p>
@@ -17846,7 +17846,7 @@
                 <a:ea typeface="Courier New" pitchFamily="34" charset="-122"/>
                 <a:cs typeface="Courier New" pitchFamily="34" charset="-120"/>
               </a:rPr>
-              <a:t>Turn this conversation's triage setup into a reusable</a:t>
+              <a:t>Create a skill named donna-triage from this</a:t>
             </a:r>
             <a:endParaRPr lang="en-US" sz="1600" dirty="0"/>
           </a:p>
@@ -17866,7 +17866,7 @@
                 <a:ea typeface="Courier New" pitchFamily="34" charset="-122"/>
                 <a:cs typeface="Courier New" pitchFamily="34" charset="-120"/>
               </a:rPr>
-              <a:t>skill named donna-triage. Fill in the template with</a:t>
+              <a:t>conversation's triage setup. Fill in the template with</a:t>
             </a:r>
             <a:endParaRPr lang="en-US" sz="1600" dirty="0"/>
           </a:p>
@@ -17926,7 +17926,7 @@
                 <a:ea typeface="Courier New" pitchFamily="34" charset="-122"/>
                 <a:cs typeface="Courier New" pitchFamily="34" charset="-120"/>
               </a:rPr>
-              <a:t>hard rules: never send, never delete. Give me the</a:t>
+              <a:t>hard rules: never send, never delete. Create it as a</a:t>
             </a:r>
             <a:endParaRPr lang="en-US" sz="1600" dirty="0"/>
           </a:p>
@@ -17946,7 +17946,7 @@
                 <a:ea typeface="Courier New" pitchFamily="34" charset="-122"/>
                 <a:cs typeface="Courier New" pitchFamily="34" charset="-120"/>
               </a:rPr>
-              <a:t>skill as a downloadable zip named donna-triage.zip</a:t>
+              <a:t>skill right here in this chat so I can save it with</a:t>
             </a:r>
             <a:endParaRPr lang="en-US" sz="1600" dirty="0"/>
           </a:p>
@@ -17966,7 +17966,7 @@
                 <a:ea typeface="Courier New" pitchFamily="34" charset="-122"/>
                 <a:cs typeface="Courier New" pitchFamily="34" charset="-120"/>
               </a:rPr>
-              <a:t>containing donna-triage/SKILL.md.</a:t>
+              <a:t>one click. Do not give me a zip to download.</a:t>
             </a:r>
             <a:endParaRPr lang="en-US" sz="1600" dirty="0"/>
           </a:p>
@@ -18053,7 +18053,7 @@
                 <a:ea typeface="Arial" pitchFamily="34" charset="-122"/>
                 <a:cs typeface="Arial" pitchFamily="34" charset="-120"/>
               </a:rPr>
-              <a:t>Full prompt on the site, Step 3. See donna-triage in your skills list before anyone touches Scheduled.</a:t>
+              <a:t>Full prompt on the site, Step 3. Click Save on her skill card, then see donna-triage under Customize, Skills.</a:t>
             </a:r>
             <a:endParaRPr lang="en-US" sz="1600" dirty="0"/>
           </a:p>
@@ -18146,7 +18146,7 @@
         <p:spPr>
           <a:xfrm>
             <a:off x="9098280" y="2171639"/>
-            <a:ext cx="2286000" cy="347472"/>
+            <a:ext cx="2286000" cy="603504"/>
           </a:xfrm>
           <a:prstGeom prst="rect">
             <a:avLst/>
@@ -18173,7 +18173,7 @@
                 <a:ea typeface="Arial" pitchFamily="34" charset="-122"/>
                 <a:cs typeface="Arial" pitchFamily="34" charset="-120"/>
               </a:rPr>
-              <a:t>She writes the file.</a:t>
+              <a:t>She writes the skill, in the chat.</a:t>
             </a:r>
             <a:endParaRPr lang="en-US" sz="1600" dirty="0"/>
           </a:p>
@@ -18187,7 +18187,7 @@
         </p:nvSpPr>
         <p:spPr>
           <a:xfrm>
-            <a:off x="8494776" y="2756855"/>
+            <a:off x="8494776" y="2939735"/>
             <a:ext cx="457200" cy="420624"/>
           </a:xfrm>
           <a:prstGeom prst="rect">
@@ -18226,7 +18226,7 @@
         </p:nvSpPr>
         <p:spPr>
           <a:xfrm>
-            <a:off x="9098280" y="2793431"/>
+            <a:off x="9098280" y="2976311"/>
             <a:ext cx="2286000" cy="603504"/>
           </a:xfrm>
           <a:prstGeom prst="rect">
@@ -18254,7 +18254,7 @@
                 <a:ea typeface="Arial" pitchFamily="34" charset="-122"/>
                 <a:cs typeface="Arial" pitchFamily="34" charset="-120"/>
               </a:rPr>
-              <a:t>Download it: the file card's arrow.</a:t>
+              <a:t>Click Save on the skill card.</a:t>
             </a:r>
             <a:endParaRPr lang="en-US" sz="1600" dirty="0"/>
           </a:p>
@@ -18268,7 +18268,7 @@
         </p:nvSpPr>
         <p:spPr>
           <a:xfrm>
-            <a:off x="8494776" y="3561527"/>
+            <a:off x="8494776" y="3744407"/>
             <a:ext cx="457200" cy="420624"/>
           </a:xfrm>
           <a:prstGeom prst="rect">
@@ -18307,8 +18307,8 @@
         </p:nvSpPr>
         <p:spPr>
           <a:xfrm>
-            <a:off x="9098280" y="3598103"/>
-            <a:ext cx="2286000" cy="1115568"/>
+            <a:off x="9098280" y="3780983"/>
+            <a:ext cx="2286000" cy="603504"/>
           </a:xfrm>
           <a:prstGeom prst="rect">
             <a:avLst/>
@@ -18335,7 +18335,7 @@
                 <a:ea typeface="Arial" pitchFamily="34" charset="-122"/>
                 <a:cs typeface="Arial" pitchFamily="34" charset="-120"/>
               </a:rPr>
-              <a:t>Customize, Skills, +, Create skill, Upload a skill. Pick the zip.</a:t>
+              <a:t>Customize, Skills: donna-triage is on.</a:t>
             </a:r>
             <a:endParaRPr lang="en-US" sz="1600" dirty="0"/>
           </a:p>
@@ -25934,7 +25934,7 @@
                 <a:ea typeface="Arial" pitchFamily="34" charset="-122"/>
                 <a:cs typeface="Arial" pitchFamily="34" charset="-120"/>
               </a:rPr>
-              <a:t>one paste, one upload</a:t>
+              <a:t>one paste, one Save</a:t>
             </a:r>
             <a:endParaRPr lang="en-US" sz="1600" dirty="0"/>
           </a:p>

</xml_diff>

<commit_message>
Step 3 prompt no longer names the Friday retrain (it keeps every template section instead)
Co-Authored-By: Claude Fable 5.1 <noreply@anthropic.com>
Claude-Session: https://claude.ai/code/session_0193JnwZiFkcYnyNggnZj1Hm
</commit_message>
<xml_diff>
--- a/decks/build-your-own-donna-v3.pptx
+++ b/decks/build-your-own-donna-v3.pptx
@@ -17760,7 +17760,7 @@
         <p:spPr>
           <a:xfrm>
             <a:off x="813816" y="1677863"/>
-            <a:ext cx="7315200" cy="2496312"/>
+            <a:ext cx="7315200" cy="2743200"/>
           </a:xfrm>
           <a:prstGeom prst="rect">
             <a:avLst/>
@@ -17819,7 +17819,7 @@
         <p:spPr>
           <a:xfrm>
             <a:off x="1069848" y="2189927"/>
-            <a:ext cx="6803136" cy="1856232"/>
+            <a:ext cx="6803136" cy="2103120"/>
           </a:xfrm>
           <a:prstGeom prst="rect">
             <a:avLst/>
@@ -17886,7 +17886,7 @@
                 <a:ea typeface="Courier New" pitchFamily="34" charset="-122"/>
                 <a:cs typeface="Courier New" pitchFamily="34" charset="-120"/>
               </a:rPr>
-              <a:t>everything you learned about me. Keep the daily shift,</a:t>
+              <a:t>everything you learned about me. Keep every section of</a:t>
             </a:r>
             <a:endParaRPr lang="en-US" sz="1600" dirty="0"/>
           </a:p>
@@ -17906,7 +17906,7 @@
                 <a:ea typeface="Courier New" pitchFamily="34" charset="-122"/>
                 <a:cs typeface="Courier New" pitchFamily="34" charset="-120"/>
               </a:rPr>
-              <a:t>the Friday retrain, and the Setup Interview. Keep the</a:t>
+              <a:t>the template, including the daily shift and the Setup</a:t>
             </a:r>
             <a:endParaRPr lang="en-US" sz="1600" dirty="0"/>
           </a:p>
@@ -17926,7 +17926,7 @@
                 <a:ea typeface="Courier New" pitchFamily="34" charset="-122"/>
                 <a:cs typeface="Courier New" pitchFamily="34" charset="-120"/>
               </a:rPr>
-              <a:t>hard rules: never send, never delete. Create it as a</a:t>
+              <a:t>Interview. Keep the hard rules: never send, never</a:t>
             </a:r>
             <a:endParaRPr lang="en-US" sz="1600" dirty="0"/>
           </a:p>
@@ -17946,7 +17946,7 @@
                 <a:ea typeface="Courier New" pitchFamily="34" charset="-122"/>
                 <a:cs typeface="Courier New" pitchFamily="34" charset="-120"/>
               </a:rPr>
-              <a:t>skill right here in this chat so I can save it with</a:t>
+              <a:t>delete. Create it as a skill right here in this chat</a:t>
             </a:r>
             <a:endParaRPr lang="en-US" sz="1600" dirty="0"/>
           </a:p>
@@ -17966,7 +17966,27 @@
                 <a:ea typeface="Courier New" pitchFamily="34" charset="-122"/>
                 <a:cs typeface="Courier New" pitchFamily="34" charset="-120"/>
               </a:rPr>
-              <a:t>one click. Do not give me a zip to download.</a:t>
+              <a:t>so I can save it with one click. Do not give me a zip</a:t>
+            </a:r>
+            <a:endParaRPr lang="en-US" sz="1600" dirty="0"/>
+          </a:p>
+          <a:p>
+            <a:pPr indent="0" marL="0">
+              <a:lnSpc>
+                <a:spcPts val="1940"/>
+              </a:lnSpc>
+              <a:buNone/>
+            </a:pPr>
+            <a:r>
+              <a:rPr lang="en-US" sz="1600" dirty="0">
+                <a:solidFill>
+                  <a:srgbClr val="F7F3EA"/>
+                </a:solidFill>
+                <a:latin typeface="Courier New" pitchFamily="34" charset="0"/>
+                <a:ea typeface="Courier New" pitchFamily="34" charset="-122"/>
+                <a:cs typeface="Courier New" pitchFamily="34" charset="-120"/>
+              </a:rPr>
+              <a:t>to download.</a:t>
             </a:r>
             <a:endParaRPr lang="en-US" sz="1600" dirty="0"/>
           </a:p>
@@ -17980,7 +18000,7 @@
         </p:nvSpPr>
         <p:spPr>
           <a:xfrm>
-            <a:off x="813816" y="4357055"/>
+            <a:off x="813816" y="4603943"/>
             <a:ext cx="7315200" cy="969264"/>
           </a:xfrm>
           <a:prstGeom prst="rect">
@@ -18000,7 +18020,7 @@
         </p:nvSpPr>
         <p:spPr>
           <a:xfrm rot="2700000">
-            <a:off x="996696" y="4617659"/>
+            <a:off x="996696" y="4864547"/>
             <a:ext cx="100584" cy="100584"/>
           </a:xfrm>
           <a:prstGeom prst="rect">
@@ -18025,7 +18045,7 @@
         </p:nvSpPr>
         <p:spPr>
           <a:xfrm>
-            <a:off x="1307592" y="4539935"/>
+            <a:off x="1307592" y="4786823"/>
             <a:ext cx="6638544" cy="603504"/>
           </a:xfrm>
           <a:prstGeom prst="rect">

</xml_diff>